<commit_message>
docs: added evaluation section to poster
Added the Evaluation section to the project poster, summarising the model comparison process, evaluation metrics, class imbalance considerations and final model selection.

Included the overall model comparison table to support the selection of Decision Tree – Full Dataset Balanced Tuned 2 as the final IDS model.
</commit_message>
<xml_diff>
--- a/Poster Presentation.pptx
+++ b/Poster Presentation.pptx
@@ -286,7 +286,7 @@
             <a:fld id="{0158C5BC-9A70-462C-B28D-9600239EAC64}" type="datetimeFigureOut">
               <a:rPr lang="en-US" smtClean="0"/>
               <a:pPr/>
-              <a:t>5/27/2026</a:t>
+              <a:t>5/27/26</a:t>
             </a:fld>
             <a:endParaRPr lang="en-US"/>
           </a:p>
@@ -353,7 +353,7 @@
             <a:fld id="{79C131B7-05CA-4AEE-9267-6D0ED4DC84F3}" type="slidenum">
               <a:rPr lang="en-US" smtClean="0"/>
               <a:pPr/>
-              <a:t>‹nº›</a:t>
+              <a:t>‹#›</a:t>
             </a:fld>
             <a:endParaRPr lang="en-US"/>
           </a:p>
@@ -453,7 +453,7 @@
             <a:fld id="{E6CC2317-6751-4CD4-9995-8782DD78E936}" type="datetimeFigureOut">
               <a:rPr lang="en-US" smtClean="0"/>
               <a:pPr/>
-              <a:t>5/27/2026</a:t>
+              <a:t>5/27/26</a:t>
             </a:fld>
             <a:endParaRPr lang="en-US" dirty="0"/>
           </a:p>
@@ -614,7 +614,7 @@
             <a:fld id="{26A1A87D-CAF7-4BDC-A0D3-C0DBEDE81619}" type="slidenum">
               <a:rPr lang="en-US" smtClean="0"/>
               <a:pPr/>
-              <a:t>‹nº›</a:t>
+              <a:t>‹#›</a:t>
             </a:fld>
             <a:endParaRPr lang="en-US" dirty="0"/>
           </a:p>
@@ -14456,187 +14456,6 @@
           </a:p>
         </p:txBody>
       </p:sp>
-      <p:pic>
-        <p:nvPicPr>
-          <p:cNvPr id="4098" name="Picture 2"/>
-          <p:cNvPicPr>
-            <a:picLocks noChangeAspect="1" noChangeArrowheads="1"/>
-          </p:cNvPicPr>
-          <p:nvPr/>
-        </p:nvPicPr>
-        <p:blipFill>
-          <a:blip r:embed="rId3">
-            <a:extLst>
-              <a:ext uri="{28A0092B-C50C-407E-A947-70E740481C1C}">
-                <a14:useLocalDpi xmlns:a14="http://schemas.microsoft.com/office/drawing/2010/main" val="0"/>
-              </a:ext>
-            </a:extLst>
-          </a:blip>
-          <a:srcRect/>
-          <a:stretch>
-            <a:fillRect/>
-          </a:stretch>
-        </p:blipFill>
-        <p:spPr bwMode="auto">
-          <a:xfrm>
-            <a:off x="33408415" y="10820362"/>
-            <a:ext cx="9841664" cy="5223653"/>
-          </a:xfrm>
-          <a:prstGeom prst="rect">
-            <a:avLst/>
-          </a:prstGeom>
-          <a:noFill/>
-          <a:ln>
-            <a:noFill/>
-          </a:ln>
-          <a:extLst>
-            <a:ext uri="{909E8E84-426E-40DD-AFC4-6F175D3DCCD1}">
-              <a14:hiddenFill xmlns:a14="http://schemas.microsoft.com/office/drawing/2010/main">
-                <a:solidFill>
-                  <a:schemeClr val="accent1"/>
-                </a:solidFill>
-              </a14:hiddenFill>
-            </a:ext>
-            <a:ext uri="{91240B29-F687-4F45-9708-019B960494DF}">
-              <a14:hiddenLine xmlns:a14="http://schemas.microsoft.com/office/drawing/2010/main" w="9525">
-                <a:solidFill>
-                  <a:schemeClr val="tx1"/>
-                </a:solidFill>
-                <a:miter lim="800000"/>
-                <a:headEnd/>
-                <a:tailEnd/>
-              </a14:hiddenLine>
-            </a:ext>
-          </a:extLst>
-        </p:spPr>
-      </p:pic>
-      <p:pic>
-        <p:nvPicPr>
-          <p:cNvPr id="19" name="Picture 3"/>
-          <p:cNvPicPr>
-            <a:picLocks noChangeAspect="1" noChangeArrowheads="1"/>
-          </p:cNvPicPr>
-          <p:nvPr/>
-        </p:nvPicPr>
-        <p:blipFill>
-          <a:blip r:embed="rId4">
-            <a:extLst>
-              <a:ext uri="{28A0092B-C50C-407E-A947-70E740481C1C}">
-                <a14:useLocalDpi xmlns:a14="http://schemas.microsoft.com/office/drawing/2010/main" val="0"/>
-              </a:ext>
-            </a:extLst>
-          </a:blip>
-          <a:srcRect/>
-          <a:stretch>
-            <a:fillRect/>
-          </a:stretch>
-        </p:blipFill>
-        <p:spPr bwMode="auto">
-          <a:xfrm>
-            <a:off x="33392567" y="16426199"/>
-            <a:ext cx="9857512" cy="5248213"/>
-          </a:xfrm>
-          <a:prstGeom prst="rect">
-            <a:avLst/>
-          </a:prstGeom>
-          <a:noFill/>
-          <a:ln>
-            <a:noFill/>
-          </a:ln>
-          <a:extLst>
-            <a:ext uri="{909E8E84-426E-40DD-AFC4-6F175D3DCCD1}">
-              <a14:hiddenFill xmlns:a14="http://schemas.microsoft.com/office/drawing/2010/main">
-                <a:solidFill>
-                  <a:schemeClr val="accent1"/>
-                </a:solidFill>
-              </a14:hiddenFill>
-            </a:ext>
-            <a:ext uri="{91240B29-F687-4F45-9708-019B960494DF}">
-              <a14:hiddenLine xmlns:a14="http://schemas.microsoft.com/office/drawing/2010/main" w="9525">
-                <a:solidFill>
-                  <a:schemeClr val="tx1"/>
-                </a:solidFill>
-                <a:miter lim="800000"/>
-                <a:headEnd/>
-                <a:tailEnd/>
-              </a14:hiddenLine>
-            </a:ext>
-          </a:extLst>
-        </p:spPr>
-      </p:pic>
-      <p:sp>
-        <p:nvSpPr>
-          <p:cNvPr id="30" name="Text Placeholder 6"/>
-          <p:cNvSpPr>
-            <a:spLocks noGrp="1"/>
-          </p:cNvSpPr>
-          <p:nvPr>
-            <p:ph type="body" sz="quarter" idx="23"/>
-          </p:nvPr>
-        </p:nvSpPr>
-        <p:spPr>
-          <a:xfrm>
-            <a:off x="33371596" y="5536712"/>
-            <a:ext cx="10048874" cy="846363"/>
-          </a:xfrm>
-        </p:spPr>
-        <p:txBody>
-          <a:bodyPr/>
-          <a:lstStyle/>
-          <a:p>
-            <a:r>
-              <a:rPr lang="en-US" i="1" u="sng" dirty="0">
-                <a:solidFill>
-                  <a:schemeClr val="tx2"/>
-                </a:solidFill>
-                <a:latin typeface="Arial" panose="020B0604020202020204" pitchFamily="34" charset="0"/>
-                <a:cs typeface="Arial" panose="020B0604020202020204" pitchFamily="34" charset="0"/>
-              </a:rPr>
-              <a:t>Self Efficacy</a:t>
-            </a:r>
-          </a:p>
-        </p:txBody>
-      </p:sp>
-      <p:sp>
-        <p:nvSpPr>
-          <p:cNvPr id="31" name="Text Placeholder 11"/>
-          <p:cNvSpPr>
-            <a:spLocks noGrp="1"/>
-          </p:cNvSpPr>
-          <p:nvPr>
-            <p:ph type="body" sz="quarter" idx="28"/>
-          </p:nvPr>
-        </p:nvSpPr>
-        <p:spPr>
-          <a:xfrm>
-            <a:off x="33382622" y="6056596"/>
-            <a:ext cx="10052050" cy="4693570"/>
-          </a:xfrm>
-        </p:spPr>
-        <p:txBody>
-          <a:bodyPr/>
-          <a:lstStyle/>
-          <a:p>
-            <a:r>
-              <a:rPr lang="en-IE" dirty="0">
-                <a:solidFill>
-                  <a:schemeClr val="tx1"/>
-                </a:solidFill>
-                <a:latin typeface="Arial" panose="020B0604020202020204" pitchFamily="34" charset="0"/>
-                <a:cs typeface="Arial" panose="020B0604020202020204" pitchFamily="34" charset="0"/>
-              </a:rPr>
-              <a:t>Participants were provided a self-efficacy questionnaire, based on a approach suggested by Bandura (2006), to complete at the start and end of a semester. A social learning intervention was introduced to a treatment group, and the overall self-efficacy group score comparison revealed very little, other than a slight increase in the treatment group score.  However, a significant finding was found when comparing the final four questions measuring the perceived ability to work within a group. To illustrate this, the first figure below represents the start of semester self-efficacy group score for both groups, followed by the second figure representing the end of semester self-efficacy score reversal.</a:t>
-            </a:r>
-            <a:endParaRPr lang="en-US" dirty="0">
-              <a:solidFill>
-                <a:schemeClr val="tx1"/>
-              </a:solidFill>
-              <a:latin typeface="Arial" panose="020B0604020202020204" pitchFamily="34" charset="0"/>
-              <a:cs typeface="Arial" panose="020B0604020202020204" pitchFamily="34" charset="0"/>
-            </a:endParaRPr>
-          </a:p>
-        </p:txBody>
-      </p:sp>
       <p:sp>
         <p:nvSpPr>
           <p:cNvPr id="32" name="Content Placeholder 2"/>
@@ -16021,7 +15840,7 @@
           <p:nvPr/>
         </p:nvPicPr>
         <p:blipFill>
-          <a:blip r:embed="rId5">
+          <a:blip r:embed="rId3">
             <a:extLst>
               <a:ext uri="{28A0092B-C50C-407E-A947-70E740481C1C}">
                 <a14:useLocalDpi xmlns:a14="http://schemas.microsoft.com/office/drawing/2010/main" val="0"/>
@@ -16473,7 +16292,7 @@
           <p:nvPr/>
         </p:nvPicPr>
         <p:blipFill>
-          <a:blip r:embed="rId6">
+          <a:blip r:embed="rId4">
             <a:extLst>
               <a:ext uri="{28A0092B-C50C-407E-A947-70E740481C1C}">
                 <a14:useLocalDpi xmlns:a14="http://schemas.microsoft.com/office/drawing/2010/main" val="0"/>
@@ -17229,7 +17048,7 @@
           <p:nvPr/>
         </p:nvPicPr>
         <p:blipFill>
-          <a:blip r:embed="rId7">
+          <a:blip r:embed="rId5">
             <a:extLst>
               <a:ext uri="{28A0092B-C50C-407E-A947-70E740481C1C}">
                 <a14:useLocalDpi xmlns:a14="http://schemas.microsoft.com/office/drawing/2010/main" val="0"/>
@@ -17250,31 +17069,6 @@
           </a:prstGeom>
         </p:spPr>
       </p:pic>
-      <p:sp>
-        <p:nvSpPr>
-          <p:cNvPr id="4113" name="Text Placeholder 4112">
-            <a:extLst>
-              <a:ext uri="{FF2B5EF4-FFF2-40B4-BE49-F238E27FC236}">
-                <a16:creationId xmlns:a16="http://schemas.microsoft.com/office/drawing/2014/main" id="{C3E8964B-EB47-3109-E00C-B3251A6A5F96}"/>
-              </a:ext>
-            </a:extLst>
-          </p:cNvPr>
-          <p:cNvSpPr>
-            <a:spLocks noGrp="1"/>
-          </p:cNvSpPr>
-          <p:nvPr>
-            <p:ph type="body" sz="quarter" idx="28"/>
-          </p:nvPr>
-        </p:nvSpPr>
-        <p:spPr/>
-        <p:txBody>
-          <a:bodyPr/>
-          <a:lstStyle/>
-          <a:p>
-            <a:endParaRPr lang="en-IE"/>
-          </a:p>
-        </p:txBody>
-      </p:sp>
       <p:sp>
         <p:nvSpPr>
           <p:cNvPr id="4116" name="Text Placeholder 5">
@@ -17472,7 +17266,7 @@
         </p:nvSpPr>
         <p:spPr>
           <a:xfrm>
-            <a:off x="23207225" y="24690506"/>
+            <a:off x="33358099" y="5807125"/>
             <a:ext cx="10047018" cy="677100"/>
           </a:xfrm>
           <a:prstGeom prst="rect">
@@ -17652,7 +17446,7 @@
           <p:nvPr/>
         </p:nvPicPr>
         <p:blipFill>
-          <a:blip r:embed="rId8">
+          <a:blip r:embed="rId6">
             <a:extLst>
               <a:ext uri="{28A0092B-C50C-407E-A947-70E740481C1C}">
                 <a14:useLocalDpi xmlns:a14="http://schemas.microsoft.com/office/drawing/2010/main" val="0"/>
@@ -18017,7 +17811,7 @@
                   <a:schemeClr val="tx1"/>
                 </a:solidFill>
               </a:rPr>
-              <a:t>Decision Tree and Random Forest were trained on the raw datasets, while Logistic Regression used scaled data because it is sensitive to feature magnitude.</a:t>
+              <a:t>Decision Tree and Random Forest were trained on the raw datasets, while Logistic Regression used scaled data because it is sensitive to feature magnitude (Nugroho et al., 2018).</a:t>
             </a:r>
           </a:p>
           <a:p>
@@ -18117,6 +17911,303 @@
           </a:p>
         </p:txBody>
       </p:sp>
+      <p:sp>
+        <p:nvSpPr>
+          <p:cNvPr id="8" name="Text Placeholder 4">
+            <a:extLst>
+              <a:ext uri="{FF2B5EF4-FFF2-40B4-BE49-F238E27FC236}">
+                <a16:creationId xmlns:a16="http://schemas.microsoft.com/office/drawing/2014/main" id="{9983B177-5CEB-A5A3-9EBD-A40E726C2D0D}"/>
+              </a:ext>
+            </a:extLst>
+          </p:cNvPr>
+          <p:cNvSpPr txBox="1">
+            <a:spLocks/>
+          </p:cNvSpPr>
+          <p:nvPr/>
+        </p:nvSpPr>
+        <p:spPr>
+          <a:xfrm>
+            <a:off x="22421124" y="14468658"/>
+            <a:ext cx="10048874" cy="7463559"/>
+          </a:xfrm>
+          <a:prstGeom prst="rect">
+            <a:avLst/>
+          </a:prstGeom>
+        </p:spPr>
+        <p:txBody>
+          <a:bodyPr wrap="square" lIns="228589" tIns="228589" rIns="228589" bIns="228589">
+            <a:spAutoFit/>
+          </a:bodyPr>
+          <a:lstStyle>
+            <a:lvl1pPr marL="0" indent="0" algn="l" defTabSz="4388900" rtl="0" eaLnBrk="1" latinLnBrk="0" hangingPunct="1">
+              <a:spcBef>
+                <a:spcPct val="20000"/>
+              </a:spcBef>
+              <a:buFont typeface="Arial" pitchFamily="34" charset="0"/>
+              <a:buNone/>
+              <a:defRPr sz="2500" kern="1200">
+                <a:solidFill>
+                  <a:schemeClr val="accent5">
+                    <a:lumMod val="50000"/>
+                  </a:schemeClr>
+                </a:solidFill>
+                <a:latin typeface="Times New Roman" pitchFamily="18" charset="0"/>
+                <a:ea typeface="+mn-ea"/>
+                <a:cs typeface="Times New Roman" pitchFamily="18" charset="0"/>
+              </a:defRPr>
+            </a:lvl1pPr>
+            <a:lvl2pPr marL="1485825" indent="-571471" algn="l" defTabSz="4388900" rtl="0" eaLnBrk="1" latinLnBrk="0" hangingPunct="1">
+              <a:spcBef>
+                <a:spcPct val="20000"/>
+              </a:spcBef>
+              <a:buFont typeface="Arial" pitchFamily="34" charset="0"/>
+              <a:buChar char="–"/>
+              <a:defRPr sz="2500" kern="1200">
+                <a:solidFill>
+                  <a:schemeClr val="tx1"/>
+                </a:solidFill>
+                <a:latin typeface="Trebuchet MS" pitchFamily="34" charset="0"/>
+                <a:ea typeface="+mn-ea"/>
+                <a:cs typeface="+mn-cs"/>
+              </a:defRPr>
+            </a:lvl2pPr>
+            <a:lvl3pPr marL="2057297" indent="-571471" algn="l" defTabSz="4388900" rtl="0" eaLnBrk="1" latinLnBrk="0" hangingPunct="1">
+              <a:spcBef>
+                <a:spcPct val="20000"/>
+              </a:spcBef>
+              <a:buFont typeface="Arial" pitchFamily="34" charset="0"/>
+              <a:buChar char="•"/>
+              <a:defRPr sz="2500" kern="1200">
+                <a:solidFill>
+                  <a:schemeClr val="tx1"/>
+                </a:solidFill>
+                <a:latin typeface="Trebuchet MS" pitchFamily="34" charset="0"/>
+                <a:ea typeface="+mn-ea"/>
+                <a:cs typeface="+mn-cs"/>
+              </a:defRPr>
+            </a:lvl3pPr>
+            <a:lvl4pPr marL="2685916" indent="-628619" algn="l" defTabSz="4388900" rtl="0" eaLnBrk="1" latinLnBrk="0" hangingPunct="1">
+              <a:spcBef>
+                <a:spcPct val="20000"/>
+              </a:spcBef>
+              <a:buFont typeface="Arial" pitchFamily="34" charset="0"/>
+              <a:buChar char="–"/>
+              <a:defRPr sz="2500" kern="1200">
+                <a:solidFill>
+                  <a:schemeClr val="tx1"/>
+                </a:solidFill>
+                <a:latin typeface="Trebuchet MS" pitchFamily="34" charset="0"/>
+                <a:ea typeface="+mn-ea"/>
+                <a:cs typeface="+mn-cs"/>
+              </a:defRPr>
+            </a:lvl4pPr>
+            <a:lvl5pPr marL="3143093" indent="-457177" algn="l" defTabSz="4388900" rtl="0" eaLnBrk="1" latinLnBrk="0" hangingPunct="1">
+              <a:spcBef>
+                <a:spcPct val="20000"/>
+              </a:spcBef>
+              <a:buFont typeface="Arial" pitchFamily="34" charset="0"/>
+              <a:buChar char="»"/>
+              <a:defRPr sz="2500" kern="1200">
+                <a:solidFill>
+                  <a:schemeClr val="tx1"/>
+                </a:solidFill>
+                <a:latin typeface="Trebuchet MS" pitchFamily="34" charset="0"/>
+                <a:ea typeface="+mn-ea"/>
+                <a:cs typeface="+mn-cs"/>
+              </a:defRPr>
+            </a:lvl5pPr>
+            <a:lvl6pPr marL="12069477" indent="-1097226" algn="l" defTabSz="4388900" rtl="0" eaLnBrk="1" latinLnBrk="0" hangingPunct="1">
+              <a:spcBef>
+                <a:spcPct val="20000"/>
+              </a:spcBef>
+              <a:buFont typeface="Arial" pitchFamily="34" charset="0"/>
+              <a:buChar char="•"/>
+              <a:defRPr sz="9600" kern="1200">
+                <a:solidFill>
+                  <a:schemeClr val="tx1"/>
+                </a:solidFill>
+                <a:latin typeface="+mn-lt"/>
+                <a:ea typeface="+mn-ea"/>
+                <a:cs typeface="+mn-cs"/>
+              </a:defRPr>
+            </a:lvl6pPr>
+            <a:lvl7pPr marL="14263926" indent="-1097226" algn="l" defTabSz="4388900" rtl="0" eaLnBrk="1" latinLnBrk="0" hangingPunct="1">
+              <a:spcBef>
+                <a:spcPct val="20000"/>
+              </a:spcBef>
+              <a:buFont typeface="Arial" pitchFamily="34" charset="0"/>
+              <a:buChar char="•"/>
+              <a:defRPr sz="9600" kern="1200">
+                <a:solidFill>
+                  <a:schemeClr val="tx1"/>
+                </a:solidFill>
+                <a:latin typeface="+mn-lt"/>
+                <a:ea typeface="+mn-ea"/>
+                <a:cs typeface="+mn-cs"/>
+              </a:defRPr>
+            </a:lvl7pPr>
+            <a:lvl8pPr marL="16458377" indent="-1097226" algn="l" defTabSz="4388900" rtl="0" eaLnBrk="1" latinLnBrk="0" hangingPunct="1">
+              <a:spcBef>
+                <a:spcPct val="20000"/>
+              </a:spcBef>
+              <a:buFont typeface="Arial" pitchFamily="34" charset="0"/>
+              <a:buChar char="•"/>
+              <a:defRPr sz="9600" kern="1200">
+                <a:solidFill>
+                  <a:schemeClr val="tx1"/>
+                </a:solidFill>
+                <a:latin typeface="+mn-lt"/>
+                <a:ea typeface="+mn-ea"/>
+                <a:cs typeface="+mn-cs"/>
+              </a:defRPr>
+            </a:lvl8pPr>
+            <a:lvl9pPr marL="18652827" indent="-1097226" algn="l" defTabSz="4388900" rtl="0" eaLnBrk="1" latinLnBrk="0" hangingPunct="1">
+              <a:spcBef>
+                <a:spcPct val="20000"/>
+              </a:spcBef>
+              <a:buFont typeface="Arial" pitchFamily="34" charset="0"/>
+              <a:buChar char="•"/>
+              <a:defRPr sz="9600" kern="1200">
+                <a:solidFill>
+                  <a:schemeClr val="tx1"/>
+                </a:solidFill>
+                <a:latin typeface="+mn-lt"/>
+                <a:ea typeface="+mn-ea"/>
+                <a:cs typeface="+mn-cs"/>
+              </a:defRPr>
+            </a:lvl9pPr>
+          </a:lstStyle>
+          <a:p>
+            <a:pPr algn="just"/>
+            <a:r>
+              <a:rPr lang="en-US" dirty="0">
+                <a:solidFill>
+                  <a:schemeClr val="tx1"/>
+                </a:solidFill>
+              </a:rPr>
+              <a:t>Models were evaluated using accuracy, precision, recall, macro F1-score, weighted F1-score, confusion matrix and training time (Müller and Guido, 2017).</a:t>
+            </a:r>
+          </a:p>
+          <a:p>
+            <a:pPr algn="just"/>
+            <a:r>
+              <a:rPr lang="en-US" dirty="0">
+                <a:solidFill>
+                  <a:schemeClr val="tx1"/>
+                </a:solidFill>
+              </a:rPr>
+              <a:t>Accuracy alone was not enough because the dataset was highly imbalanced. Macro F1-score was important because it gives equal weight to each class, including rare attacks.</a:t>
+            </a:r>
+          </a:p>
+          <a:p>
+            <a:pPr algn="just"/>
+            <a:r>
+              <a:rPr lang="en-US" dirty="0">
+                <a:solidFill>
+                  <a:schemeClr val="tx1"/>
+                </a:solidFill>
+              </a:rPr>
+              <a:t>Logistic Regression was the weakest model. It struggled with minority attack classes and had higher training time.</a:t>
+            </a:r>
+          </a:p>
+          <a:p>
+            <a:pPr algn="just"/>
+            <a:r>
+              <a:rPr lang="en-US" dirty="0">
+                <a:solidFill>
+                  <a:schemeClr val="tx1"/>
+                </a:solidFill>
+              </a:rPr>
+              <a:t>Random Forest achieved strong results, but it was heavier and less suitable for the lightweight objective.</a:t>
+            </a:r>
+          </a:p>
+          <a:p>
+            <a:pPr algn="just"/>
+            <a:r>
+              <a:rPr lang="en-US" dirty="0">
+                <a:solidFill>
+                  <a:schemeClr val="tx1"/>
+                </a:solidFill>
+              </a:rPr>
+              <a:t>Decision Tree gave the best balance between classification performance, runtime efficiency, interpretability and attack coverage. </a:t>
+            </a:r>
+          </a:p>
+          <a:p>
+            <a:pPr algn="just"/>
+            <a:r>
+              <a:rPr lang="en-US" dirty="0">
+                <a:solidFill>
+                  <a:schemeClr val="tx1"/>
+                </a:solidFill>
+              </a:rPr>
+              <a:t>The final selected model was </a:t>
+            </a:r>
+            <a:r>
+              <a:rPr lang="en-US" b="1" dirty="0">
+                <a:solidFill>
+                  <a:schemeClr val="tx1"/>
+                </a:solidFill>
+              </a:rPr>
+              <a:t>Decision Tree – Full Dataset Balanced Tuned 2.</a:t>
+            </a:r>
+          </a:p>
+          <a:p>
+            <a:pPr algn="just"/>
+            <a:r>
+              <a:rPr lang="en-US" dirty="0">
+                <a:solidFill>
+                  <a:schemeClr val="tx1"/>
+                </a:solidFill>
+              </a:rPr>
+              <a:t>This model kept all traffic classes and performed strongly on the main classes, while still detecting some rare attacks such as Heartbleed, Infiltration and SQL Injection</a:t>
+            </a:r>
+            <a:r>
+              <a:rPr lang="en-US" sz="2000" dirty="0">
+                <a:solidFill>
+                  <a:schemeClr val="tx1"/>
+                </a:solidFill>
+              </a:rPr>
+              <a:t>.</a:t>
+            </a:r>
+          </a:p>
+        </p:txBody>
+      </p:sp>
+      <p:pic>
+        <p:nvPicPr>
+          <p:cNvPr id="14" name="Picture 13">
+            <a:extLst>
+              <a:ext uri="{FF2B5EF4-FFF2-40B4-BE49-F238E27FC236}">
+                <a16:creationId xmlns:a16="http://schemas.microsoft.com/office/drawing/2014/main" id="{0DA51407-45C4-3DA7-FA70-D31ABB284391}"/>
+              </a:ext>
+            </a:extLst>
+          </p:cNvPr>
+          <p:cNvPicPr>
+            <a:picLocks noChangeAspect="1"/>
+          </p:cNvPicPr>
+          <p:nvPr/>
+        </p:nvPicPr>
+        <p:blipFill>
+          <a:blip r:embed="rId7">
+            <a:extLst>
+              <a:ext uri="{28A0092B-C50C-407E-A947-70E740481C1C}">
+                <a14:useLocalDpi xmlns:a14="http://schemas.microsoft.com/office/drawing/2010/main" val="0"/>
+              </a:ext>
+            </a:extLst>
+          </a:blip>
+          <a:stretch>
+            <a:fillRect/>
+          </a:stretch>
+        </p:blipFill>
+        <p:spPr>
+          <a:xfrm>
+            <a:off x="22971033" y="21908743"/>
+            <a:ext cx="8891903" cy="7117465"/>
+          </a:xfrm>
+          <a:prstGeom prst="rect">
+            <a:avLst/>
+          </a:prstGeom>
+        </p:spPr>
+      </p:pic>
     </p:spTree>
     <p:extLst>
       <p:ext uri="{BB962C8B-B14F-4D97-AF65-F5344CB8AC3E}">

</xml_diff>

<commit_message>
docs: added poster deployment and conclusion sections
Added the Deployment and Conclusion sections to the project poster.

Summarised the Streamlit dashboard prototype, including CSV upload, required feature checks, traffic prediction, benign/suspicious traffic summaries, prediction download and feature importance.

Added a brief conclusion highlighting the final Decision Tree model, lightweight IDS objective, prototype value and remaining limitations before real-world deployment.
</commit_message>
<xml_diff>
--- a/Poster Presentation.pptx
+++ b/Poster Presentation.pptx
@@ -14329,7 +14329,7 @@
         </p:nvSpPr>
         <p:spPr>
           <a:xfrm>
-            <a:off x="33346443" y="21931197"/>
+            <a:off x="33346443" y="24461559"/>
             <a:ext cx="10047018" cy="677100"/>
           </a:xfrm>
         </p:spPr>
@@ -14965,301 +14965,6 @@
                 <a:cs typeface="Times New Roman" panose="02020603050405020304" pitchFamily="18" charset="0"/>
               </a:rPr>
               <a:t>	What limitations remain in the selected model?</a:t>
-            </a:r>
-          </a:p>
-        </p:txBody>
-      </p:sp>
-      <p:sp>
-        <p:nvSpPr>
-          <p:cNvPr id="42" name="Content Placeholder 2"/>
-          <p:cNvSpPr txBox="1">
-            <a:spLocks/>
-          </p:cNvSpPr>
-          <p:nvPr/>
-        </p:nvSpPr>
-        <p:spPr>
-          <a:xfrm>
-            <a:off x="33513137" y="22823005"/>
-            <a:ext cx="9736942" cy="5408649"/>
-          </a:xfrm>
-          <a:prstGeom prst="rect">
-            <a:avLst/>
-          </a:prstGeom>
-        </p:spPr>
-        <p:txBody>
-          <a:bodyPr>
-            <a:noAutofit/>
-          </a:bodyPr>
-          <a:lstStyle>
-            <a:lvl1pPr marL="1645838" indent="-1645838" algn="l" defTabSz="4388900" rtl="0" eaLnBrk="1" latinLnBrk="0" hangingPunct="1">
-              <a:spcBef>
-                <a:spcPct val="20000"/>
-              </a:spcBef>
-              <a:buFont typeface="Arial" pitchFamily="34" charset="0"/>
-              <a:buChar char="•"/>
-              <a:defRPr sz="15400" kern="1200">
-                <a:solidFill>
-                  <a:schemeClr val="tx1"/>
-                </a:solidFill>
-                <a:latin typeface="+mn-lt"/>
-                <a:ea typeface="+mn-ea"/>
-                <a:cs typeface="+mn-cs"/>
-              </a:defRPr>
-            </a:lvl1pPr>
-            <a:lvl2pPr marL="3565982" indent="-1371531" algn="l" defTabSz="4388900" rtl="0" eaLnBrk="1" latinLnBrk="0" hangingPunct="1">
-              <a:spcBef>
-                <a:spcPct val="20000"/>
-              </a:spcBef>
-              <a:buFont typeface="Arial" pitchFamily="34" charset="0"/>
-              <a:buChar char="–"/>
-              <a:defRPr sz="13500" kern="1200">
-                <a:solidFill>
-                  <a:schemeClr val="tx1"/>
-                </a:solidFill>
-                <a:latin typeface="+mn-lt"/>
-                <a:ea typeface="+mn-ea"/>
-                <a:cs typeface="+mn-cs"/>
-              </a:defRPr>
-            </a:lvl2pPr>
-            <a:lvl3pPr marL="5486126" indent="-1097226" algn="l" defTabSz="4388900" rtl="0" eaLnBrk="1" latinLnBrk="0" hangingPunct="1">
-              <a:spcBef>
-                <a:spcPct val="20000"/>
-              </a:spcBef>
-              <a:buFont typeface="Arial" pitchFamily="34" charset="0"/>
-              <a:buChar char="•"/>
-              <a:defRPr sz="11600" kern="1200">
-                <a:solidFill>
-                  <a:schemeClr val="tx1"/>
-                </a:solidFill>
-                <a:latin typeface="+mn-lt"/>
-                <a:ea typeface="+mn-ea"/>
-                <a:cs typeface="+mn-cs"/>
-              </a:defRPr>
-            </a:lvl3pPr>
-            <a:lvl4pPr marL="7680577" indent="-1097226" algn="l" defTabSz="4388900" rtl="0" eaLnBrk="1" latinLnBrk="0" hangingPunct="1">
-              <a:spcBef>
-                <a:spcPct val="20000"/>
-              </a:spcBef>
-              <a:buFont typeface="Arial" pitchFamily="34" charset="0"/>
-              <a:buChar char="–"/>
-              <a:defRPr sz="9600" kern="1200">
-                <a:solidFill>
-                  <a:schemeClr val="tx1"/>
-                </a:solidFill>
-                <a:latin typeface="+mn-lt"/>
-                <a:ea typeface="+mn-ea"/>
-                <a:cs typeface="+mn-cs"/>
-              </a:defRPr>
-            </a:lvl4pPr>
-            <a:lvl5pPr marL="9875026" indent="-1097226" algn="l" defTabSz="4388900" rtl="0" eaLnBrk="1" latinLnBrk="0" hangingPunct="1">
-              <a:spcBef>
-                <a:spcPct val="20000"/>
-              </a:spcBef>
-              <a:buFont typeface="Arial" pitchFamily="34" charset="0"/>
-              <a:buChar char="»"/>
-              <a:defRPr sz="9600" kern="1200">
-                <a:solidFill>
-                  <a:schemeClr val="tx1"/>
-                </a:solidFill>
-                <a:latin typeface="+mn-lt"/>
-                <a:ea typeface="+mn-ea"/>
-                <a:cs typeface="+mn-cs"/>
-              </a:defRPr>
-            </a:lvl5pPr>
-            <a:lvl6pPr marL="12069477" indent="-1097226" algn="l" defTabSz="4388900" rtl="0" eaLnBrk="1" latinLnBrk="0" hangingPunct="1">
-              <a:spcBef>
-                <a:spcPct val="20000"/>
-              </a:spcBef>
-              <a:buFont typeface="Arial" pitchFamily="34" charset="0"/>
-              <a:buChar char="•"/>
-              <a:defRPr sz="9600" kern="1200">
-                <a:solidFill>
-                  <a:schemeClr val="tx1"/>
-                </a:solidFill>
-                <a:latin typeface="+mn-lt"/>
-                <a:ea typeface="+mn-ea"/>
-                <a:cs typeface="+mn-cs"/>
-              </a:defRPr>
-            </a:lvl6pPr>
-            <a:lvl7pPr marL="14263926" indent="-1097226" algn="l" defTabSz="4388900" rtl="0" eaLnBrk="1" latinLnBrk="0" hangingPunct="1">
-              <a:spcBef>
-                <a:spcPct val="20000"/>
-              </a:spcBef>
-              <a:buFont typeface="Arial" pitchFamily="34" charset="0"/>
-              <a:buChar char="•"/>
-              <a:defRPr sz="9600" kern="1200">
-                <a:solidFill>
-                  <a:schemeClr val="tx1"/>
-                </a:solidFill>
-                <a:latin typeface="+mn-lt"/>
-                <a:ea typeface="+mn-ea"/>
-                <a:cs typeface="+mn-cs"/>
-              </a:defRPr>
-            </a:lvl7pPr>
-            <a:lvl8pPr marL="16458377" indent="-1097226" algn="l" defTabSz="4388900" rtl="0" eaLnBrk="1" latinLnBrk="0" hangingPunct="1">
-              <a:spcBef>
-                <a:spcPct val="20000"/>
-              </a:spcBef>
-              <a:buFont typeface="Arial" pitchFamily="34" charset="0"/>
-              <a:buChar char="•"/>
-              <a:defRPr sz="9600" kern="1200">
-                <a:solidFill>
-                  <a:schemeClr val="tx1"/>
-                </a:solidFill>
-                <a:latin typeface="+mn-lt"/>
-                <a:ea typeface="+mn-ea"/>
-                <a:cs typeface="+mn-cs"/>
-              </a:defRPr>
-            </a:lvl8pPr>
-            <a:lvl9pPr marL="18652827" indent="-1097226" algn="l" defTabSz="4388900" rtl="0" eaLnBrk="1" latinLnBrk="0" hangingPunct="1">
-              <a:spcBef>
-                <a:spcPct val="20000"/>
-              </a:spcBef>
-              <a:buFont typeface="Arial" pitchFamily="34" charset="0"/>
-              <a:buChar char="•"/>
-              <a:defRPr sz="9600" kern="1200">
-                <a:solidFill>
-                  <a:schemeClr val="tx1"/>
-                </a:solidFill>
-                <a:latin typeface="+mn-lt"/>
-                <a:ea typeface="+mn-ea"/>
-                <a:cs typeface="+mn-cs"/>
-              </a:defRPr>
-            </a:lvl9pPr>
-          </a:lstStyle>
-          <a:p>
-            <a:pPr marL="0" indent="0" algn="just" defTabSz="895350">
-              <a:buFont typeface="Arial" pitchFamily="34" charset="0"/>
-              <a:buNone/>
-            </a:pPr>
-            <a:r>
-              <a:rPr lang="en-IE" sz="2400" dirty="0">
-                <a:latin typeface="Arial" panose="020B0604020202020204" pitchFamily="34" charset="0"/>
-                <a:cs typeface="Arial" panose="020B0604020202020204" pitchFamily="34" charset="0"/>
-              </a:rPr>
-              <a:t>A summarised answer to the research questions are presented below:</a:t>
-            </a:r>
-          </a:p>
-          <a:p>
-            <a:pPr marL="0" indent="0" algn="just" defTabSz="895350">
-              <a:buFont typeface="Arial" pitchFamily="34" charset="0"/>
-              <a:buNone/>
-            </a:pPr>
-            <a:endParaRPr lang="en-IE" sz="1000" dirty="0">
-              <a:latin typeface="Arial" panose="020B0604020202020204" pitchFamily="34" charset="0"/>
-              <a:cs typeface="Arial" panose="020B0604020202020204" pitchFamily="34" charset="0"/>
-            </a:endParaRPr>
-          </a:p>
-          <a:p>
-            <a:pPr marL="0" indent="0" defTabSz="895350">
-              <a:buFont typeface="Arial" pitchFamily="34" charset="0"/>
-              <a:buNone/>
-            </a:pPr>
-            <a:r>
-              <a:rPr lang="en-IE" sz="2200" b="1" dirty="0">
-                <a:latin typeface="Arial" panose="020B0604020202020204" pitchFamily="34" charset="0"/>
-                <a:cs typeface="Arial" panose="020B0604020202020204" pitchFamily="34" charset="0"/>
-              </a:rPr>
-              <a:t>Q.1.</a:t>
-            </a:r>
-            <a:r>
-              <a:rPr lang="en-IE" sz="2200" dirty="0">
-                <a:latin typeface="Arial" panose="020B0604020202020204" pitchFamily="34" charset="0"/>
-                <a:cs typeface="Arial" panose="020B0604020202020204" pitchFamily="34" charset="0"/>
-              </a:rPr>
-              <a:t> 	</a:t>
-            </a:r>
-            <a:r>
-              <a:rPr lang="en-IE" sz="2200" i="1" dirty="0">
-                <a:latin typeface="Arial" panose="020B0604020202020204" pitchFamily="34" charset="0"/>
-                <a:cs typeface="Arial" panose="020B0604020202020204" pitchFamily="34" charset="0"/>
-              </a:rPr>
-              <a:t>Both of the studies on the use of a reflective learning journal were 	mostly negative, in that students did not find it beneficial, and in some 	cases, saw it as an additional ungraded piece of assessment .</a:t>
-            </a:r>
-          </a:p>
-          <a:p>
-            <a:pPr marL="0" indent="0" defTabSz="895350">
-              <a:buFont typeface="Arial" pitchFamily="34" charset="0"/>
-              <a:buNone/>
-            </a:pPr>
-            <a:r>
-              <a:rPr lang="en-IE" sz="2200" b="1" dirty="0">
-                <a:latin typeface="Arial" panose="020B0604020202020204" pitchFamily="34" charset="0"/>
-                <a:cs typeface="Arial" panose="020B0604020202020204" pitchFamily="34" charset="0"/>
-              </a:rPr>
-              <a:t>Q.2. </a:t>
-            </a:r>
-            <a:r>
-              <a:rPr lang="en-IE" sz="2200" dirty="0">
-                <a:latin typeface="Arial" panose="020B0604020202020204" pitchFamily="34" charset="0"/>
-                <a:cs typeface="Arial" panose="020B0604020202020204" pitchFamily="34" charset="0"/>
-              </a:rPr>
-              <a:t>	There was </a:t>
-            </a:r>
-            <a:r>
-              <a:rPr lang="en-IE" sz="2200" i="1" dirty="0">
-                <a:latin typeface="Arial" panose="020B0604020202020204" pitchFamily="34" charset="0"/>
-                <a:cs typeface="Arial" panose="020B0604020202020204" pitchFamily="34" charset="0"/>
-              </a:rPr>
-              <a:t>evidence to suggest it does, specifically relating to 	group based activities, and communicating with peers.  However, it is 	difficult to say positive findings were directly linked to the social 	learning activities introduced over the semester.</a:t>
-            </a:r>
-            <a:endParaRPr lang="en-IE" sz="2200" dirty="0">
-              <a:latin typeface="Arial" panose="020B0604020202020204" pitchFamily="34" charset="0"/>
-              <a:cs typeface="Arial" panose="020B0604020202020204" pitchFamily="34" charset="0"/>
-            </a:endParaRPr>
-          </a:p>
-          <a:p>
-            <a:pPr marL="0" indent="0" defTabSz="895350">
-              <a:buFont typeface="Arial" pitchFamily="34" charset="0"/>
-              <a:buNone/>
-            </a:pPr>
-            <a:r>
-              <a:rPr lang="en-IE" sz="2200" b="1" dirty="0">
-                <a:latin typeface="Arial" panose="020B0604020202020204" pitchFamily="34" charset="0"/>
-                <a:cs typeface="Arial" panose="020B0604020202020204" pitchFamily="34" charset="0"/>
-              </a:rPr>
-              <a:t>Q.3 </a:t>
-            </a:r>
-            <a:r>
-              <a:rPr lang="en-IE" sz="2200" dirty="0">
-                <a:latin typeface="Arial" panose="020B0604020202020204" pitchFamily="34" charset="0"/>
-                <a:cs typeface="Arial" panose="020B0604020202020204" pitchFamily="34" charset="0"/>
-              </a:rPr>
-              <a:t>	</a:t>
-            </a:r>
-            <a:r>
-              <a:rPr lang="en-IE" sz="2200" i="1" dirty="0">
-                <a:latin typeface="Arial" panose="020B0604020202020204" pitchFamily="34" charset="0"/>
-                <a:cs typeface="Arial" panose="020B0604020202020204" pitchFamily="34" charset="0"/>
-              </a:rPr>
-              <a:t>The use of PBL and PAL was very successful in engaging students in 	computer programming, the students engaged in the activities and 	requested more of these activities in the future.</a:t>
-            </a:r>
-          </a:p>
-          <a:p>
-            <a:pPr marL="0" indent="0" defTabSz="895350">
-              <a:buFont typeface="Arial" pitchFamily="34" charset="0"/>
-              <a:buNone/>
-            </a:pPr>
-            <a:r>
-              <a:rPr lang="en-IE" sz="2200" b="1" dirty="0">
-                <a:latin typeface="Arial" panose="020B0604020202020204" pitchFamily="34" charset="0"/>
-                <a:cs typeface="Arial" panose="020B0604020202020204" pitchFamily="34" charset="0"/>
-              </a:rPr>
-              <a:t>Q.4</a:t>
-            </a:r>
-            <a:r>
-              <a:rPr lang="en-IE" sz="2200" dirty="0">
-                <a:latin typeface="Arial" panose="020B0604020202020204" pitchFamily="34" charset="0"/>
-                <a:cs typeface="Arial" panose="020B0604020202020204" pitchFamily="34" charset="0"/>
-              </a:rPr>
-              <a:t>	</a:t>
-            </a:r>
-            <a:r>
-              <a:rPr lang="en-IE" sz="2200" i="1" dirty="0">
-                <a:latin typeface="Arial" panose="020B0604020202020204" pitchFamily="34" charset="0"/>
-                <a:cs typeface="Arial" panose="020B0604020202020204" pitchFamily="34" charset="0"/>
-              </a:rPr>
-              <a:t>There was no strong evidence to suggest social learning improved 	self-efficacy in computer programming, however, there was strong 	evidence found that participating in group work enhances self-efficacy 	in working with others in group activities.</a:t>
             </a:r>
           </a:p>
         </p:txBody>
@@ -18208,6 +17913,555 @@
           </a:prstGeom>
         </p:spPr>
       </p:pic>
+      <p:sp>
+        <p:nvSpPr>
+          <p:cNvPr id="10" name="Text Placeholder 4">
+            <a:extLst>
+              <a:ext uri="{FF2B5EF4-FFF2-40B4-BE49-F238E27FC236}">
+                <a16:creationId xmlns:a16="http://schemas.microsoft.com/office/drawing/2014/main" id="{9C2CD7EE-7990-9502-DD2C-3B95F92DA7C0}"/>
+              </a:ext>
+            </a:extLst>
+          </p:cNvPr>
+          <p:cNvSpPr txBox="1">
+            <a:spLocks/>
+          </p:cNvSpPr>
+          <p:nvPr/>
+        </p:nvSpPr>
+        <p:spPr>
+          <a:xfrm>
+            <a:off x="33382622" y="6439621"/>
+            <a:ext cx="10048874" cy="5309123"/>
+          </a:xfrm>
+          <a:prstGeom prst="rect">
+            <a:avLst/>
+          </a:prstGeom>
+        </p:spPr>
+        <p:txBody>
+          <a:bodyPr wrap="square" lIns="228589" tIns="228589" rIns="228589" bIns="228589">
+            <a:spAutoFit/>
+          </a:bodyPr>
+          <a:lstStyle>
+            <a:lvl1pPr marL="0" indent="0" algn="l" defTabSz="4388900" rtl="0" eaLnBrk="1" latinLnBrk="0" hangingPunct="1">
+              <a:spcBef>
+                <a:spcPct val="20000"/>
+              </a:spcBef>
+              <a:buFont typeface="Arial" pitchFamily="34" charset="0"/>
+              <a:buNone/>
+              <a:defRPr sz="2500" kern="1200">
+                <a:solidFill>
+                  <a:schemeClr val="accent5">
+                    <a:lumMod val="50000"/>
+                  </a:schemeClr>
+                </a:solidFill>
+                <a:latin typeface="Times New Roman" pitchFamily="18" charset="0"/>
+                <a:ea typeface="+mn-ea"/>
+                <a:cs typeface="Times New Roman" pitchFamily="18" charset="0"/>
+              </a:defRPr>
+            </a:lvl1pPr>
+            <a:lvl2pPr marL="1485825" indent="-571471" algn="l" defTabSz="4388900" rtl="0" eaLnBrk="1" latinLnBrk="0" hangingPunct="1">
+              <a:spcBef>
+                <a:spcPct val="20000"/>
+              </a:spcBef>
+              <a:buFont typeface="Arial" pitchFamily="34" charset="0"/>
+              <a:buChar char="–"/>
+              <a:defRPr sz="2500" kern="1200">
+                <a:solidFill>
+                  <a:schemeClr val="tx1"/>
+                </a:solidFill>
+                <a:latin typeface="Trebuchet MS" pitchFamily="34" charset="0"/>
+                <a:ea typeface="+mn-ea"/>
+                <a:cs typeface="+mn-cs"/>
+              </a:defRPr>
+            </a:lvl2pPr>
+            <a:lvl3pPr marL="2057297" indent="-571471" algn="l" defTabSz="4388900" rtl="0" eaLnBrk="1" latinLnBrk="0" hangingPunct="1">
+              <a:spcBef>
+                <a:spcPct val="20000"/>
+              </a:spcBef>
+              <a:buFont typeface="Arial" pitchFamily="34" charset="0"/>
+              <a:buChar char="•"/>
+              <a:defRPr sz="2500" kern="1200">
+                <a:solidFill>
+                  <a:schemeClr val="tx1"/>
+                </a:solidFill>
+                <a:latin typeface="Trebuchet MS" pitchFamily="34" charset="0"/>
+                <a:ea typeface="+mn-ea"/>
+                <a:cs typeface="+mn-cs"/>
+              </a:defRPr>
+            </a:lvl3pPr>
+            <a:lvl4pPr marL="2685916" indent="-628619" algn="l" defTabSz="4388900" rtl="0" eaLnBrk="1" latinLnBrk="0" hangingPunct="1">
+              <a:spcBef>
+                <a:spcPct val="20000"/>
+              </a:spcBef>
+              <a:buFont typeface="Arial" pitchFamily="34" charset="0"/>
+              <a:buChar char="–"/>
+              <a:defRPr sz="2500" kern="1200">
+                <a:solidFill>
+                  <a:schemeClr val="tx1"/>
+                </a:solidFill>
+                <a:latin typeface="Trebuchet MS" pitchFamily="34" charset="0"/>
+                <a:ea typeface="+mn-ea"/>
+                <a:cs typeface="+mn-cs"/>
+              </a:defRPr>
+            </a:lvl4pPr>
+            <a:lvl5pPr marL="3143093" indent="-457177" algn="l" defTabSz="4388900" rtl="0" eaLnBrk="1" latinLnBrk="0" hangingPunct="1">
+              <a:spcBef>
+                <a:spcPct val="20000"/>
+              </a:spcBef>
+              <a:buFont typeface="Arial" pitchFamily="34" charset="0"/>
+              <a:buChar char="»"/>
+              <a:defRPr sz="2500" kern="1200">
+                <a:solidFill>
+                  <a:schemeClr val="tx1"/>
+                </a:solidFill>
+                <a:latin typeface="Trebuchet MS" pitchFamily="34" charset="0"/>
+                <a:ea typeface="+mn-ea"/>
+                <a:cs typeface="+mn-cs"/>
+              </a:defRPr>
+            </a:lvl5pPr>
+            <a:lvl6pPr marL="12069477" indent="-1097226" algn="l" defTabSz="4388900" rtl="0" eaLnBrk="1" latinLnBrk="0" hangingPunct="1">
+              <a:spcBef>
+                <a:spcPct val="20000"/>
+              </a:spcBef>
+              <a:buFont typeface="Arial" pitchFamily="34" charset="0"/>
+              <a:buChar char="•"/>
+              <a:defRPr sz="9600" kern="1200">
+                <a:solidFill>
+                  <a:schemeClr val="tx1"/>
+                </a:solidFill>
+                <a:latin typeface="+mn-lt"/>
+                <a:ea typeface="+mn-ea"/>
+                <a:cs typeface="+mn-cs"/>
+              </a:defRPr>
+            </a:lvl6pPr>
+            <a:lvl7pPr marL="14263926" indent="-1097226" algn="l" defTabSz="4388900" rtl="0" eaLnBrk="1" latinLnBrk="0" hangingPunct="1">
+              <a:spcBef>
+                <a:spcPct val="20000"/>
+              </a:spcBef>
+              <a:buFont typeface="Arial" pitchFamily="34" charset="0"/>
+              <a:buChar char="•"/>
+              <a:defRPr sz="9600" kern="1200">
+                <a:solidFill>
+                  <a:schemeClr val="tx1"/>
+                </a:solidFill>
+                <a:latin typeface="+mn-lt"/>
+                <a:ea typeface="+mn-ea"/>
+                <a:cs typeface="+mn-cs"/>
+              </a:defRPr>
+            </a:lvl7pPr>
+            <a:lvl8pPr marL="16458377" indent="-1097226" algn="l" defTabSz="4388900" rtl="0" eaLnBrk="1" latinLnBrk="0" hangingPunct="1">
+              <a:spcBef>
+                <a:spcPct val="20000"/>
+              </a:spcBef>
+              <a:buFont typeface="Arial" pitchFamily="34" charset="0"/>
+              <a:buChar char="•"/>
+              <a:defRPr sz="9600" kern="1200">
+                <a:solidFill>
+                  <a:schemeClr val="tx1"/>
+                </a:solidFill>
+                <a:latin typeface="+mn-lt"/>
+                <a:ea typeface="+mn-ea"/>
+                <a:cs typeface="+mn-cs"/>
+              </a:defRPr>
+            </a:lvl8pPr>
+            <a:lvl9pPr marL="18652827" indent="-1097226" algn="l" defTabSz="4388900" rtl="0" eaLnBrk="1" latinLnBrk="0" hangingPunct="1">
+              <a:spcBef>
+                <a:spcPct val="20000"/>
+              </a:spcBef>
+              <a:buFont typeface="Arial" pitchFamily="34" charset="0"/>
+              <a:buChar char="•"/>
+              <a:defRPr sz="9600" kern="1200">
+                <a:solidFill>
+                  <a:schemeClr val="tx1"/>
+                </a:solidFill>
+                <a:latin typeface="+mn-lt"/>
+                <a:ea typeface="+mn-ea"/>
+                <a:cs typeface="+mn-cs"/>
+              </a:defRPr>
+            </a:lvl9pPr>
+          </a:lstStyle>
+          <a:p>
+            <a:pPr algn="just"/>
+            <a:r>
+              <a:rPr lang="en-US" dirty="0">
+                <a:solidFill>
+                  <a:schemeClr val="tx1"/>
+                </a:solidFill>
+              </a:rPr>
+              <a:t>A </a:t>
+            </a:r>
+            <a:r>
+              <a:rPr lang="en-US" dirty="0" err="1">
+                <a:solidFill>
+                  <a:schemeClr val="tx1"/>
+                </a:solidFill>
+              </a:rPr>
+              <a:t>Streamlit</a:t>
+            </a:r>
+            <a:r>
+              <a:rPr lang="en-US" dirty="0">
+                <a:solidFill>
+                  <a:schemeClr val="tx1"/>
+                </a:solidFill>
+              </a:rPr>
+              <a:t> dashboard prototype was created to demonstrate how the final model could be reused outside the notebook (</a:t>
+            </a:r>
+            <a:r>
+              <a:rPr lang="en-US" dirty="0" err="1">
+                <a:solidFill>
+                  <a:schemeClr val="tx1"/>
+                </a:solidFill>
+              </a:rPr>
+              <a:t>Streamlit</a:t>
+            </a:r>
+            <a:r>
+              <a:rPr lang="en-US" dirty="0">
+                <a:solidFill>
+                  <a:schemeClr val="tx1"/>
+                </a:solidFill>
+              </a:rPr>
+              <a:t>, 2024).</a:t>
+            </a:r>
+          </a:p>
+          <a:p>
+            <a:pPr algn="just"/>
+            <a:r>
+              <a:rPr lang="en-US" dirty="0">
+                <a:solidFill>
+                  <a:schemeClr val="tx1"/>
+                </a:solidFill>
+              </a:rPr>
+              <a:t>The final Decision Tree model was saved using </a:t>
+            </a:r>
+            <a:r>
+              <a:rPr lang="en-US" dirty="0" err="1">
+                <a:solidFill>
+                  <a:schemeClr val="tx1"/>
+                </a:solidFill>
+              </a:rPr>
+              <a:t>Joblib</a:t>
+            </a:r>
+            <a:r>
+              <a:rPr lang="en-US" dirty="0">
+                <a:solidFill>
+                  <a:schemeClr val="tx1"/>
+                </a:solidFill>
+              </a:rPr>
+              <a:t> together with the selected 39 features, label encoder, and trained model file (McQuaid, 2026d).</a:t>
+            </a:r>
+          </a:p>
+          <a:p>
+            <a:pPr algn="just"/>
+            <a:r>
+              <a:rPr lang="en-US" dirty="0">
+                <a:solidFill>
+                  <a:schemeClr val="tx1"/>
+                </a:solidFill>
+              </a:rPr>
+              <a:t>The dashboard allows the user to upload a CSV file with network flow records, check if the required features are present, run traffic predictions, view benign and suspicious traffic summaries, download the prediction results and view feature importance.</a:t>
+            </a:r>
+          </a:p>
+          <a:p>
+            <a:pPr algn="just"/>
+            <a:r>
+              <a:rPr lang="en-US" dirty="0">
+                <a:solidFill>
+                  <a:schemeClr val="tx1"/>
+                </a:solidFill>
+              </a:rPr>
+              <a:t>This is still a prototype, not a full production IDS. It does not capture live network packets directly yet. Future work would require live traffic extraction, more testing, newer data and model retraining.</a:t>
+            </a:r>
+          </a:p>
+        </p:txBody>
+      </p:sp>
+      <p:pic>
+        <p:nvPicPr>
+          <p:cNvPr id="13" name="Picture 12">
+            <a:extLst>
+              <a:ext uri="{FF2B5EF4-FFF2-40B4-BE49-F238E27FC236}">
+                <a16:creationId xmlns:a16="http://schemas.microsoft.com/office/drawing/2014/main" id="{53FC90C0-12E5-1275-3202-CA513ACABFE2}"/>
+              </a:ext>
+            </a:extLst>
+          </p:cNvPr>
+          <p:cNvPicPr>
+            <a:picLocks noChangeAspect="1"/>
+          </p:cNvPicPr>
+          <p:nvPr/>
+        </p:nvPicPr>
+        <p:blipFill>
+          <a:blip r:embed="rId8">
+            <a:extLst>
+              <a:ext uri="{28A0092B-C50C-407E-A947-70E740481C1C}">
+                <a14:useLocalDpi xmlns:a14="http://schemas.microsoft.com/office/drawing/2010/main" val="0"/>
+              </a:ext>
+            </a:extLst>
+          </a:blip>
+          <a:stretch>
+            <a:fillRect/>
+          </a:stretch>
+        </p:blipFill>
+        <p:spPr>
+          <a:xfrm>
+            <a:off x="33755535" y="11594463"/>
+            <a:ext cx="9293216" cy="3713043"/>
+          </a:xfrm>
+          <a:prstGeom prst="rect">
+            <a:avLst/>
+          </a:prstGeom>
+        </p:spPr>
+      </p:pic>
+      <p:pic>
+        <p:nvPicPr>
+          <p:cNvPr id="17" name="Picture 16">
+            <a:extLst>
+              <a:ext uri="{FF2B5EF4-FFF2-40B4-BE49-F238E27FC236}">
+                <a16:creationId xmlns:a16="http://schemas.microsoft.com/office/drawing/2014/main" id="{E091D09D-3C67-B5A2-76AE-4CE2FE13DDD9}"/>
+              </a:ext>
+            </a:extLst>
+          </p:cNvPr>
+          <p:cNvPicPr>
+            <a:picLocks noChangeAspect="1"/>
+          </p:cNvPicPr>
+          <p:nvPr/>
+        </p:nvPicPr>
+        <p:blipFill>
+          <a:blip r:embed="rId9">
+            <a:extLst>
+              <a:ext uri="{28A0092B-C50C-407E-A947-70E740481C1C}">
+                <a14:useLocalDpi xmlns:a14="http://schemas.microsoft.com/office/drawing/2010/main" val="0"/>
+              </a:ext>
+            </a:extLst>
+          </a:blip>
+          <a:stretch>
+            <a:fillRect/>
+          </a:stretch>
+        </p:blipFill>
+        <p:spPr>
+          <a:xfrm>
+            <a:off x="33754050" y="15636954"/>
+            <a:ext cx="9293216" cy="3914331"/>
+          </a:xfrm>
+          <a:prstGeom prst="rect">
+            <a:avLst/>
+          </a:prstGeom>
+        </p:spPr>
+      </p:pic>
+      <p:sp>
+        <p:nvSpPr>
+          <p:cNvPr id="19" name="TextBox 18">
+            <a:extLst>
+              <a:ext uri="{FF2B5EF4-FFF2-40B4-BE49-F238E27FC236}">
+                <a16:creationId xmlns:a16="http://schemas.microsoft.com/office/drawing/2014/main" id="{1E19198E-4066-35E1-1945-951D3D7385D1}"/>
+              </a:ext>
+            </a:extLst>
+          </p:cNvPr>
+          <p:cNvSpPr txBox="1"/>
+          <p:nvPr/>
+        </p:nvSpPr>
+        <p:spPr>
+          <a:xfrm>
+            <a:off x="36629750" y="15318342"/>
+            <a:ext cx="3503716" cy="307777"/>
+          </a:xfrm>
+          <a:prstGeom prst="rect">
+            <a:avLst/>
+          </a:prstGeom>
+          <a:noFill/>
+        </p:spPr>
+        <p:txBody>
+          <a:bodyPr wrap="none" rtlCol="0">
+            <a:spAutoFit/>
+          </a:bodyPr>
+          <a:lstStyle/>
+          <a:p>
+            <a:r>
+              <a:rPr lang="en-IE" sz="1400" i="1" dirty="0">
+                <a:latin typeface="Times New Roman" panose="02020603050405020304" pitchFamily="18" charset="0"/>
+                <a:cs typeface="Times New Roman" panose="02020603050405020304" pitchFamily="18" charset="0"/>
+              </a:rPr>
+              <a:t>Initial </a:t>
+            </a:r>
+            <a:r>
+              <a:rPr lang="en-IE" sz="1400" i="1" dirty="0" err="1">
+                <a:latin typeface="Times New Roman" panose="02020603050405020304" pitchFamily="18" charset="0"/>
+                <a:cs typeface="Times New Roman" panose="02020603050405020304" pitchFamily="18" charset="0"/>
+              </a:rPr>
+              <a:t>Streamlit</a:t>
+            </a:r>
+            <a:r>
+              <a:rPr lang="en-IE" sz="1400" i="1" dirty="0">
+                <a:latin typeface="Times New Roman" panose="02020603050405020304" pitchFamily="18" charset="0"/>
+                <a:cs typeface="Times New Roman" panose="02020603050405020304" pitchFamily="18" charset="0"/>
+              </a:rPr>
+              <a:t> IDS dashboard upload screen</a:t>
+            </a:r>
+          </a:p>
+        </p:txBody>
+      </p:sp>
+      <p:sp>
+        <p:nvSpPr>
+          <p:cNvPr id="20" name="TextBox 19">
+            <a:extLst>
+              <a:ext uri="{FF2B5EF4-FFF2-40B4-BE49-F238E27FC236}">
+                <a16:creationId xmlns:a16="http://schemas.microsoft.com/office/drawing/2014/main" id="{D134E12D-9076-D003-5302-67A468C2934B}"/>
+              </a:ext>
+            </a:extLst>
+          </p:cNvPr>
+          <p:cNvSpPr txBox="1"/>
+          <p:nvPr/>
+        </p:nvSpPr>
+        <p:spPr>
+          <a:xfrm>
+            <a:off x="35515919" y="19533620"/>
+            <a:ext cx="5731377" cy="307777"/>
+          </a:xfrm>
+          <a:prstGeom prst="rect">
+            <a:avLst/>
+          </a:prstGeom>
+          <a:noFill/>
+        </p:spPr>
+        <p:txBody>
+          <a:bodyPr wrap="none" rtlCol="0">
+            <a:spAutoFit/>
+          </a:bodyPr>
+          <a:lstStyle/>
+          <a:p>
+            <a:r>
+              <a:rPr lang="en-US" sz="1400" dirty="0">
+                <a:latin typeface="Times New Roman" panose="02020603050405020304" pitchFamily="18" charset="0"/>
+                <a:cs typeface="Times New Roman" panose="02020603050405020304" pitchFamily="18" charset="0"/>
+              </a:rPr>
+              <a:t>Uploaded CSV preview, input preparation summary and prediction overview</a:t>
+            </a:r>
+          </a:p>
+        </p:txBody>
+      </p:sp>
+      <p:pic>
+        <p:nvPicPr>
+          <p:cNvPr id="23" name="Picture 22">
+            <a:extLst>
+              <a:ext uri="{FF2B5EF4-FFF2-40B4-BE49-F238E27FC236}">
+                <a16:creationId xmlns:a16="http://schemas.microsoft.com/office/drawing/2014/main" id="{C26A5C31-26FF-D3B0-E0A0-5FC88843E16A}"/>
+              </a:ext>
+            </a:extLst>
+          </p:cNvPr>
+          <p:cNvPicPr>
+            <a:picLocks noChangeAspect="1"/>
+          </p:cNvPicPr>
+          <p:nvPr/>
+        </p:nvPicPr>
+        <p:blipFill>
+          <a:blip r:embed="rId10">
+            <a:extLst>
+              <a:ext uri="{28A0092B-C50C-407E-A947-70E740481C1C}">
+                <a14:useLocalDpi xmlns:a14="http://schemas.microsoft.com/office/drawing/2010/main" val="0"/>
+              </a:ext>
+            </a:extLst>
+          </a:blip>
+          <a:stretch>
+            <a:fillRect/>
+          </a:stretch>
+        </p:blipFill>
+        <p:spPr>
+          <a:xfrm>
+            <a:off x="33754050" y="19853256"/>
+            <a:ext cx="9355112" cy="4234537"/>
+          </a:xfrm>
+          <a:prstGeom prst="rect">
+            <a:avLst/>
+          </a:prstGeom>
+        </p:spPr>
+      </p:pic>
+      <p:sp>
+        <p:nvSpPr>
+          <p:cNvPr id="24" name="TextBox 23">
+            <a:extLst>
+              <a:ext uri="{FF2B5EF4-FFF2-40B4-BE49-F238E27FC236}">
+                <a16:creationId xmlns:a16="http://schemas.microsoft.com/office/drawing/2014/main" id="{5D528063-B6C9-8D0A-AC8D-778F53D1AA31}"/>
+              </a:ext>
+            </a:extLst>
+          </p:cNvPr>
+          <p:cNvSpPr txBox="1"/>
+          <p:nvPr/>
+        </p:nvSpPr>
+        <p:spPr>
+          <a:xfrm>
+            <a:off x="36187584" y="24065683"/>
+            <a:ext cx="4426148" cy="307777"/>
+          </a:xfrm>
+          <a:prstGeom prst="rect">
+            <a:avLst/>
+          </a:prstGeom>
+          <a:noFill/>
+        </p:spPr>
+        <p:txBody>
+          <a:bodyPr wrap="none" rtlCol="0">
+            <a:spAutoFit/>
+          </a:bodyPr>
+          <a:lstStyle/>
+          <a:p>
+            <a:r>
+              <a:rPr lang="en-US" sz="1400" dirty="0">
+                <a:latin typeface="Times New Roman" panose="02020603050405020304" pitchFamily="18" charset="0"/>
+                <a:cs typeface="Times New Roman" panose="02020603050405020304" pitchFamily="18" charset="0"/>
+              </a:rPr>
+              <a:t>Prediction output table and predicted traffic class summary</a:t>
+            </a:r>
+          </a:p>
+        </p:txBody>
+      </p:sp>
+      <p:sp>
+        <p:nvSpPr>
+          <p:cNvPr id="26" name="TextBox 25">
+            <a:extLst>
+              <a:ext uri="{FF2B5EF4-FFF2-40B4-BE49-F238E27FC236}">
+                <a16:creationId xmlns:a16="http://schemas.microsoft.com/office/drawing/2014/main" id="{8C5AF9B8-6917-393D-C27C-9926F826EFF8}"/>
+              </a:ext>
+            </a:extLst>
+          </p:cNvPr>
+          <p:cNvSpPr txBox="1"/>
+          <p:nvPr/>
+        </p:nvSpPr>
+        <p:spPr>
+          <a:xfrm>
+            <a:off x="33566814" y="25108679"/>
+            <a:ext cx="9680489" cy="3554819"/>
+          </a:xfrm>
+          <a:prstGeom prst="rect">
+            <a:avLst/>
+          </a:prstGeom>
+          <a:noFill/>
+        </p:spPr>
+        <p:txBody>
+          <a:bodyPr wrap="square" rtlCol="0">
+            <a:spAutoFit/>
+          </a:bodyPr>
+          <a:lstStyle/>
+          <a:p>
+            <a:pPr algn="just"/>
+            <a:r>
+              <a:rPr lang="en-IE" sz="2500" dirty="0">
+                <a:latin typeface="Times New Roman" panose="02020603050405020304" pitchFamily="18" charset="0"/>
+                <a:cs typeface="Times New Roman" panose="02020603050405020304" pitchFamily="18" charset="0"/>
+              </a:rPr>
+              <a:t>The project shows that a lightweight machine learning IDS can support the detection of benign and malicious network traffic using CICIDS2017. Decision Tree – Full Dataset Balanced Tuned 2 was selected as the final model because it offered the best balance between performance, runtime, interpretability and attack coverage. The </a:t>
+            </a:r>
+            <a:r>
+              <a:rPr lang="en-IE" sz="2500" dirty="0" err="1">
+                <a:latin typeface="Times New Roman" panose="02020603050405020304" pitchFamily="18" charset="0"/>
+                <a:cs typeface="Times New Roman" panose="02020603050405020304" pitchFamily="18" charset="0"/>
+              </a:rPr>
+              <a:t>Streamlit</a:t>
+            </a:r>
+            <a:r>
+              <a:rPr lang="en-IE" sz="2500" dirty="0">
+                <a:latin typeface="Times New Roman" panose="02020603050405020304" pitchFamily="18" charset="0"/>
+                <a:cs typeface="Times New Roman" panose="02020603050405020304" pitchFamily="18" charset="0"/>
+              </a:rPr>
+              <a:t> prototype showed how the saved model could be reused for traffic prediction and suspicious traffic summaries. However, the system is still a prototype and would need newer data, live traffic extraction, further testing and retraining before real-world use.</a:t>
+            </a:r>
+          </a:p>
+        </p:txBody>
+      </p:sp>
     </p:spTree>
     <p:extLst>
       <p:ext uri="{BB962C8B-B14F-4D97-AF65-F5344CB8AC3E}">

</xml_diff>

<commit_message>
docs: updated presentation business data prep evaluation slides
Added and updated the Business Understanding, Data Preparation and Evaluation sections in the PowerPoint presentation.

Summarised the business problem, market need, project goal and success criteria for the lightweight IDS solution.

Added the Data Preparation slide content, covering target definition, feature/target separation, label encoding, correlation-based feature reduction, train/test split, dataset strategies and scaling.

Updated the Evaluation slide with the main evaluation metrics, key model findings and final selection of Decision Tree – Full Dataset Balanced Tuned 2.
</commit_message>
<xml_diff>
--- a/Poster Presentation.pptx
+++ b/Poster Presentation.pptx
@@ -252,7 +252,7 @@
             </a:lvl1pPr>
           </a:lstStyle>
           <a:p>
-            <a:endParaRPr lang="en-US"/>
+            <a:endParaRPr lang="en-US" dirty="0"/>
           </a:p>
         </p:txBody>
       </p:sp>
@@ -286,9 +286,9 @@
             <a:fld id="{0158C5BC-9A70-462C-B28D-9600239EAC64}" type="datetimeFigureOut">
               <a:rPr lang="en-US" smtClean="0"/>
               <a:pPr/>
-              <a:t>5/27/26</a:t>
+              <a:t>5/28/2026</a:t>
             </a:fld>
-            <a:endParaRPr lang="en-US"/>
+            <a:endParaRPr lang="en-US" dirty="0"/>
           </a:p>
         </p:txBody>
       </p:sp>
@@ -319,7 +319,7 @@
             </a:lvl1pPr>
           </a:lstStyle>
           <a:p>
-            <a:endParaRPr lang="en-US"/>
+            <a:endParaRPr lang="en-US" dirty="0"/>
           </a:p>
         </p:txBody>
       </p:sp>
@@ -355,7 +355,7 @@
               <a:pPr/>
               <a:t>‹#›</a:t>
             </a:fld>
-            <a:endParaRPr lang="en-US"/>
+            <a:endParaRPr lang="en-US" dirty="0"/>
           </a:p>
         </p:txBody>
       </p:sp>
@@ -453,7 +453,7 @@
             <a:fld id="{E6CC2317-6751-4CD4-9995-8782DD78E936}" type="datetimeFigureOut">
               <a:rPr lang="en-US" smtClean="0"/>
               <a:pPr/>
-              <a:t>5/27/26</a:t>
+              <a:t>5/28/2026</a:t>
             </a:fld>
             <a:endParaRPr lang="en-US" dirty="0"/>
           </a:p>
@@ -755,7 +755,7 @@
           <a:bodyPr/>
           <a:lstStyle/>
           <a:p>
-            <a:endParaRPr lang="en-IE"/>
+            <a:endParaRPr lang="en-IE" dirty="0"/>
           </a:p>
         </p:txBody>
       </p:sp>
@@ -4023,7 +4023,7 @@
           <a:lstStyle/>
           <a:p>
             <a:pPr algn="ctr"/>
-            <a:endParaRPr lang="en-US"/>
+            <a:endParaRPr lang="en-US" dirty="0"/>
           </a:p>
         </p:txBody>
       </p:sp>
@@ -4087,7 +4087,7 @@
           <a:lstStyle/>
           <a:p>
             <a:pPr algn="ctr"/>
-            <a:endParaRPr lang="en-US"/>
+            <a:endParaRPr lang="en-US" dirty="0"/>
           </a:p>
         </p:txBody>
       </p:sp>
@@ -4151,7 +4151,7 @@
           <a:lstStyle/>
           <a:p>
             <a:pPr algn="ctr"/>
-            <a:endParaRPr lang="en-US"/>
+            <a:endParaRPr lang="en-US" dirty="0"/>
           </a:p>
         </p:txBody>
       </p:sp>
@@ -4215,7 +4215,7 @@
           <a:lstStyle/>
           <a:p>
             <a:pPr algn="ctr"/>
-            <a:endParaRPr lang="en-US"/>
+            <a:endParaRPr lang="en-US" dirty="0"/>
           </a:p>
         </p:txBody>
       </p:sp>
@@ -6714,7 +6714,7 @@
               <a:lstStyle/>
               <a:p>
                 <a:pPr algn="ctr"/>
-                <a:endParaRPr lang="en-US"/>
+                <a:endParaRPr lang="en-US" dirty="0"/>
               </a:p>
             </p:txBody>
           </p:sp>
@@ -6790,25 +6790,7 @@
                     </a:solidFill>
                     <a:latin typeface="Trebuchet MS" pitchFamily="34" charset="0"/>
                   </a:rPr>
-                  <a:t> discounts are available on our </a:t>
-                </a:r>
-                <a:r>
-                  <a:rPr lang="en-US" sz="2400" baseline="0" dirty="0" err="1">
-                    <a:solidFill>
-                      <a:schemeClr val="tx2"/>
-                    </a:solidFill>
-                    <a:latin typeface="Trebuchet MS" pitchFamily="34" charset="0"/>
-                  </a:rPr>
-                  <a:t>Facebook</a:t>
-                </a:r>
-                <a:r>
-                  <a:rPr lang="en-US" sz="2400" baseline="0" dirty="0">
-                    <a:solidFill>
-                      <a:schemeClr val="tx2"/>
-                    </a:solidFill>
-                    <a:latin typeface="Trebuchet MS" pitchFamily="34" charset="0"/>
-                  </a:rPr>
-                  <a:t> page.</a:t>
+                  <a:t> discounts are available on our Facebook page.</a:t>
                 </a:r>
                 <a:br>
                   <a:rPr lang="en-US" sz="2400" baseline="0" dirty="0">
@@ -7478,7 +7460,7 @@
           <a:lstStyle/>
           <a:p>
             <a:pPr algn="ctr"/>
-            <a:endParaRPr lang="en-US"/>
+            <a:endParaRPr lang="en-US" dirty="0"/>
           </a:p>
         </p:txBody>
       </p:sp>
@@ -7545,7 +7527,7 @@
           <a:lstStyle/>
           <a:p>
             <a:pPr algn="ctr"/>
-            <a:endParaRPr lang="en-US"/>
+            <a:endParaRPr lang="en-US" dirty="0"/>
           </a:p>
         </p:txBody>
       </p:sp>
@@ -7612,7 +7594,7 @@
           <a:lstStyle/>
           <a:p>
             <a:pPr algn="ctr"/>
-            <a:endParaRPr lang="en-US"/>
+            <a:endParaRPr lang="en-US" dirty="0"/>
           </a:p>
         </p:txBody>
       </p:sp>
@@ -8780,7 +8762,7 @@
               <a:lstStyle/>
               <a:p>
                 <a:pPr algn="ctr"/>
-                <a:endParaRPr lang="en-US"/>
+                <a:endParaRPr lang="en-US" dirty="0"/>
               </a:p>
             </p:txBody>
           </p:sp>
@@ -8856,25 +8838,7 @@
                     </a:solidFill>
                     <a:latin typeface="Trebuchet MS" pitchFamily="34" charset="0"/>
                   </a:rPr>
-                  <a:t> discounts are available on our </a:t>
-                </a:r>
-                <a:r>
-                  <a:rPr lang="en-US" sz="2400" baseline="0" dirty="0" err="1">
-                    <a:solidFill>
-                      <a:schemeClr val="tx2"/>
-                    </a:solidFill>
-                    <a:latin typeface="Trebuchet MS" pitchFamily="34" charset="0"/>
-                  </a:rPr>
-                  <a:t>Facebook</a:t>
-                </a:r>
-                <a:r>
-                  <a:rPr lang="en-US" sz="2400" baseline="0" dirty="0">
-                    <a:solidFill>
-                      <a:schemeClr val="tx2"/>
-                    </a:solidFill>
-                    <a:latin typeface="Trebuchet MS" pitchFamily="34" charset="0"/>
-                  </a:rPr>
-                  <a:t> page.</a:t>
+                  <a:t> discounts are available on our Facebook page.</a:t>
                 </a:r>
                 <a:br>
                   <a:rPr lang="en-US" sz="2400" baseline="0" dirty="0">
@@ -10914,7 +10878,7 @@
           <a:lstStyle/>
           <a:p>
             <a:pPr algn="ctr"/>
-            <a:endParaRPr lang="en-US"/>
+            <a:endParaRPr lang="en-US" dirty="0"/>
           </a:p>
         </p:txBody>
       </p:sp>
@@ -10981,7 +10945,7 @@
           <a:lstStyle/>
           <a:p>
             <a:pPr algn="ctr"/>
-            <a:endParaRPr lang="en-US"/>
+            <a:endParaRPr lang="en-US" dirty="0"/>
           </a:p>
         </p:txBody>
       </p:sp>
@@ -11048,7 +11012,7 @@
           <a:lstStyle/>
           <a:p>
             <a:pPr algn="ctr"/>
-            <a:endParaRPr lang="en-US"/>
+            <a:endParaRPr lang="en-US" dirty="0"/>
           </a:p>
         </p:txBody>
       </p:sp>
@@ -12216,7 +12180,7 @@
               <a:lstStyle/>
               <a:p>
                 <a:pPr algn="ctr"/>
-                <a:endParaRPr lang="en-US"/>
+                <a:endParaRPr lang="en-US" dirty="0"/>
               </a:p>
             </p:txBody>
           </p:sp>
@@ -12292,25 +12256,7 @@
                     </a:solidFill>
                     <a:latin typeface="Trebuchet MS" pitchFamily="34" charset="0"/>
                   </a:rPr>
-                  <a:t> discounts are available on our </a:t>
-                </a:r>
-                <a:r>
-                  <a:rPr lang="en-US" sz="2400" baseline="0" dirty="0" err="1">
-                    <a:solidFill>
-                      <a:schemeClr val="tx2"/>
-                    </a:solidFill>
-                    <a:latin typeface="Trebuchet MS" pitchFamily="34" charset="0"/>
-                  </a:rPr>
-                  <a:t>Facebook</a:t>
-                </a:r>
-                <a:r>
-                  <a:rPr lang="en-US" sz="2400" baseline="0" dirty="0">
-                    <a:solidFill>
-                      <a:schemeClr val="tx2"/>
-                    </a:solidFill>
-                    <a:latin typeface="Trebuchet MS" pitchFamily="34" charset="0"/>
-                  </a:rPr>
-                  <a:t> page.</a:t>
+                  <a:t> discounts are available on our Facebook page.</a:t>
                 </a:r>
                 <a:br>
                   <a:rPr lang="en-US" sz="2400" baseline="0" dirty="0">
@@ -14296,7 +14242,7 @@
         </p:nvSpPr>
         <p:spPr>
           <a:xfrm>
-            <a:off x="498517" y="27536679"/>
+            <a:off x="498517" y="27746547"/>
             <a:ext cx="10048875" cy="754045"/>
           </a:xfrm>
         </p:spPr>
@@ -14329,7 +14275,7 @@
         </p:nvSpPr>
         <p:spPr>
           <a:xfrm>
-            <a:off x="33346443" y="24461559"/>
+            <a:off x="33346443" y="24270292"/>
             <a:ext cx="10047018" cy="677100"/>
           </a:xfrm>
         </p:spPr>
@@ -14362,8 +14308,8 @@
         </p:nvSpPr>
         <p:spPr>
           <a:xfrm>
-            <a:off x="33392567" y="28504101"/>
-            <a:ext cx="10047018" cy="754045"/>
+            <a:off x="33612021" y="29814608"/>
+            <a:ext cx="9639169" cy="738656"/>
           </a:xfrm>
         </p:spPr>
         <p:txBody>
@@ -14371,7 +14317,7 @@
           <a:lstStyle/>
           <a:p>
             <a:r>
-              <a:rPr lang="en-US" dirty="0">
+              <a:rPr lang="en-US" sz="3600" dirty="0">
                 <a:solidFill>
                   <a:schemeClr val="tx2"/>
                 </a:solidFill>
@@ -14676,7 +14622,7 @@
           <a:lstStyle/>
           <a:p>
             <a:pPr algn="ctr"/>
-            <a:endParaRPr lang="en-IE"/>
+            <a:endParaRPr lang="en-IE" dirty="0"/>
           </a:p>
         </p:txBody>
       </p:sp>
@@ -15160,8 +15106,8 @@
         </p:nvSpPr>
         <p:spPr>
           <a:xfrm>
-            <a:off x="33656519" y="29479722"/>
-            <a:ext cx="9736942" cy="2621175"/>
+            <a:off x="33591362" y="30475055"/>
+            <a:ext cx="9680488" cy="2012212"/>
           </a:xfrm>
           <a:prstGeom prst="rect">
             <a:avLst/>
@@ -15314,185 +15260,24 @@
             </a:pPr>
             <a:r>
               <a:rPr lang="en-IE" sz="900" dirty="0">
-                <a:latin typeface="Arial" panose="020B0604020202020204" pitchFamily="34" charset="0"/>
-                <a:cs typeface="Arial" panose="020B0604020202020204" pitchFamily="34" charset="0"/>
+                <a:latin typeface="Times New Roman" panose="02020603050405020304" pitchFamily="18" charset="0"/>
+                <a:cs typeface="Times New Roman" panose="02020603050405020304" pitchFamily="18" charset="0"/>
               </a:rPr>
-              <a:t>Bandura, A. (1986). Social Foundations of Thought and Action: Social Cognitive Theory. U.S.A: Pearson Education.</a:t>
-            </a:r>
-          </a:p>
-          <a:p>
-            <a:pPr marL="0" indent="0" algn="just" defTabSz="895350">
-              <a:buNone/>
-            </a:pPr>
-            <a:endParaRPr lang="en-IE" sz="900" dirty="0">
-              <a:latin typeface="Arial" panose="020B0604020202020204" pitchFamily="34" charset="0"/>
-              <a:cs typeface="Arial" panose="020B0604020202020204" pitchFamily="34" charset="0"/>
-            </a:endParaRPr>
-          </a:p>
-          <a:p>
-            <a:pPr marL="0" indent="0" algn="just" defTabSz="895350">
-              <a:buNone/>
-            </a:pPr>
-            <a:r>
-              <a:rPr lang="en-IE" sz="900" dirty="0">
-                <a:latin typeface="Arial" panose="020B0604020202020204" pitchFamily="34" charset="0"/>
-                <a:cs typeface="Arial" panose="020B0604020202020204" pitchFamily="34" charset="0"/>
-              </a:rPr>
-              <a:t>Bandura, A. (2006). Guide for constructing self-efficacy scales. In F. </a:t>
+              <a:t>McQuaid, D. (2026d) </a:t>
             </a:r>
             <a:r>
-              <a:rPr lang="en-IE" sz="900" dirty="0" err="1">
-                <a:latin typeface="Arial" panose="020B0604020202020204" pitchFamily="34" charset="0"/>
-                <a:cs typeface="Arial" panose="020B0604020202020204" pitchFamily="34" charset="0"/>
+              <a:rPr lang="en-IE" sz="900" i="1" dirty="0">
+                <a:latin typeface="Times New Roman" panose="02020603050405020304" pitchFamily="18" charset="0"/>
+                <a:cs typeface="Times New Roman" panose="02020603050405020304" pitchFamily="18" charset="0"/>
               </a:rPr>
-              <a:t>Pajares</a:t>
+              <a:t>How To Save Trained Machine Learning Models</a:t>
             </a:r>
             <a:r>
               <a:rPr lang="en-IE" sz="900" dirty="0">
-                <a:latin typeface="Arial" panose="020B0604020202020204" pitchFamily="34" charset="0"/>
-                <a:cs typeface="Arial" panose="020B0604020202020204" pitchFamily="34" charset="0"/>
+                <a:latin typeface="Times New Roman" panose="02020603050405020304" pitchFamily="18" charset="0"/>
+                <a:cs typeface="Times New Roman" panose="02020603050405020304" pitchFamily="18" charset="0"/>
               </a:rPr>
-              <a:t>, &amp; T. </a:t>
-            </a:r>
-            <a:r>
-              <a:rPr lang="en-IE" sz="900" dirty="0" err="1">
-                <a:latin typeface="Arial" panose="020B0604020202020204" pitchFamily="34" charset="0"/>
-                <a:cs typeface="Arial" panose="020B0604020202020204" pitchFamily="34" charset="0"/>
-              </a:rPr>
-              <a:t>Urdan</a:t>
-            </a:r>
-            <a:r>
-              <a:rPr lang="en-IE" sz="900" dirty="0">
-                <a:latin typeface="Arial" panose="020B0604020202020204" pitchFamily="34" charset="0"/>
-                <a:cs typeface="Arial" panose="020B0604020202020204" pitchFamily="34" charset="0"/>
-              </a:rPr>
-              <a:t> (Eds.), Adolescence and education: Vol. 5. Self efficacy and adolescence (pp. 307-337). Greenwich, CT: Information Age.</a:t>
-            </a:r>
-          </a:p>
-          <a:p>
-            <a:pPr marL="0" indent="0" algn="just" defTabSz="895350">
-              <a:buNone/>
-            </a:pPr>
-            <a:endParaRPr lang="en-IE" sz="900" dirty="0">
-              <a:latin typeface="Arial" panose="020B0604020202020204" pitchFamily="34" charset="0"/>
-              <a:cs typeface="Arial" panose="020B0604020202020204" pitchFamily="34" charset="0"/>
-            </a:endParaRPr>
-          </a:p>
-          <a:p>
-            <a:pPr marL="0" indent="0" algn="just" defTabSz="895350">
-              <a:buNone/>
-            </a:pPr>
-            <a:r>
-              <a:rPr lang="en-IE" sz="900" dirty="0">
-                <a:latin typeface="Arial" panose="020B0604020202020204" pitchFamily="34" charset="0"/>
-                <a:cs typeface="Arial" panose="020B0604020202020204" pitchFamily="34" charset="0"/>
-              </a:rPr>
-              <a:t>Bogdan, R.C., </a:t>
-            </a:r>
-            <a:r>
-              <a:rPr lang="en-IE" sz="900" dirty="0" err="1">
-                <a:latin typeface="Arial" panose="020B0604020202020204" pitchFamily="34" charset="0"/>
-                <a:cs typeface="Arial" panose="020B0604020202020204" pitchFamily="34" charset="0"/>
-              </a:rPr>
-              <a:t>Biklin</a:t>
-            </a:r>
-            <a:r>
-              <a:rPr lang="en-IE" sz="900" dirty="0">
-                <a:latin typeface="Arial" panose="020B0604020202020204" pitchFamily="34" charset="0"/>
-                <a:cs typeface="Arial" panose="020B0604020202020204" pitchFamily="34" charset="0"/>
-              </a:rPr>
-              <a:t>, S.K. (1998). Qualitative research for education: An introduction to theory and methods. (3rd edition).  Boston: </a:t>
-            </a:r>
-            <a:r>
-              <a:rPr lang="en-IE" sz="900" dirty="0" err="1">
-                <a:latin typeface="Arial" panose="020B0604020202020204" pitchFamily="34" charset="0"/>
-                <a:cs typeface="Arial" panose="020B0604020202020204" pitchFamily="34" charset="0"/>
-              </a:rPr>
-              <a:t>Allyn</a:t>
-            </a:r>
-            <a:r>
-              <a:rPr lang="en-IE" sz="900" dirty="0">
-                <a:latin typeface="Arial" panose="020B0604020202020204" pitchFamily="34" charset="0"/>
-                <a:cs typeface="Arial" panose="020B0604020202020204" pitchFamily="34" charset="0"/>
-              </a:rPr>
-              <a:t> and Bacon.</a:t>
-            </a:r>
-          </a:p>
-          <a:p>
-            <a:pPr marL="0" indent="0" algn="just" defTabSz="895350">
-              <a:buNone/>
-            </a:pPr>
-            <a:endParaRPr lang="en-IE" sz="900" dirty="0">
-              <a:latin typeface="Arial" panose="020B0604020202020204" pitchFamily="34" charset="0"/>
-              <a:cs typeface="Arial" panose="020B0604020202020204" pitchFamily="34" charset="0"/>
-            </a:endParaRPr>
-          </a:p>
-          <a:p>
-            <a:pPr marL="0" indent="0" algn="just" defTabSz="895350">
-              <a:buNone/>
-            </a:pPr>
-            <a:r>
-              <a:rPr lang="en-IE" sz="900" dirty="0">
-                <a:latin typeface="Arial" panose="020B0604020202020204" pitchFamily="34" charset="0"/>
-                <a:cs typeface="Arial" panose="020B0604020202020204" pitchFamily="34" charset="0"/>
-              </a:rPr>
-              <a:t>Bryman, A. (2004). Social Research Methods.  U.K.: Oxford University Press.</a:t>
-            </a:r>
-          </a:p>
-          <a:p>
-            <a:pPr marL="0" indent="0" algn="just" defTabSz="895350">
-              <a:buNone/>
-            </a:pPr>
-            <a:endParaRPr lang="en-IE" sz="900" dirty="0">
-              <a:latin typeface="Arial" panose="020B0604020202020204" pitchFamily="34" charset="0"/>
-              <a:cs typeface="Arial" panose="020B0604020202020204" pitchFamily="34" charset="0"/>
-            </a:endParaRPr>
-          </a:p>
-          <a:p>
-            <a:pPr marL="0" indent="0" algn="just" defTabSz="895350">
-              <a:buNone/>
-            </a:pPr>
-            <a:r>
-              <a:rPr lang="en-IE" sz="900" dirty="0">
-                <a:latin typeface="Arial" panose="020B0604020202020204" pitchFamily="34" charset="0"/>
-                <a:cs typeface="Arial" panose="020B0604020202020204" pitchFamily="34" charset="0"/>
-              </a:rPr>
-              <a:t>Creswell, J.W., Miller, G.A. (1997).  Research Methodologies and Doctoral Process.  New Directions for Higher Education, no.99.  U.S.A.: Wiley.</a:t>
-            </a:r>
-          </a:p>
-          <a:p>
-            <a:pPr marL="0" indent="0" algn="just" defTabSz="895350">
-              <a:buNone/>
-            </a:pPr>
-            <a:endParaRPr lang="en-IE" sz="900" dirty="0">
-              <a:latin typeface="Arial" panose="020B0604020202020204" pitchFamily="34" charset="0"/>
-              <a:cs typeface="Arial" panose="020B0604020202020204" pitchFamily="34" charset="0"/>
-            </a:endParaRPr>
-          </a:p>
-          <a:p>
-            <a:pPr marL="0" indent="0" algn="just" defTabSz="895350">
-              <a:buNone/>
-            </a:pPr>
-            <a:r>
-              <a:rPr lang="en-IE" sz="900" dirty="0">
-                <a:latin typeface="Arial" panose="020B0604020202020204" pitchFamily="34" charset="0"/>
-                <a:cs typeface="Arial" panose="020B0604020202020204" pitchFamily="34" charset="0"/>
-              </a:rPr>
-              <a:t>Hamir, S., </a:t>
-            </a:r>
-            <a:r>
-              <a:rPr lang="en-IE" sz="900" dirty="0" err="1">
-                <a:latin typeface="Arial" panose="020B0604020202020204" pitchFamily="34" charset="0"/>
-                <a:cs typeface="Arial" panose="020B0604020202020204" pitchFamily="34" charset="0"/>
-              </a:rPr>
-              <a:t>Maion</a:t>
-            </a:r>
-            <a:r>
-              <a:rPr lang="en-IE" sz="900" dirty="0">
-                <a:latin typeface="Arial" panose="020B0604020202020204" pitchFamily="34" charset="0"/>
-                <a:cs typeface="Arial" panose="020B0604020202020204" pitchFamily="34" charset="0"/>
-              </a:rPr>
-              <a:t>, S., Tice, S., &amp; Wideman, A. (2015) Constructivism in</a:t>
+              <a:t>. Machine Learning for AI lecture notes. CCT College Dublin. </a:t>
             </a:r>
           </a:p>
           <a:p>
@@ -15501,10 +15286,168 @@
             </a:pPr>
             <a:r>
               <a:rPr lang="en-IE" sz="900" dirty="0">
-                <a:latin typeface="Arial" panose="020B0604020202020204" pitchFamily="34" charset="0"/>
-                <a:cs typeface="Arial" panose="020B0604020202020204" pitchFamily="34" charset="0"/>
+                <a:latin typeface="Times New Roman" panose="02020603050405020304" pitchFamily="18" charset="0"/>
+                <a:cs typeface="Times New Roman" panose="02020603050405020304" pitchFamily="18" charset="0"/>
               </a:rPr>
-              <a:t>Education. Available at: http://constructivism512.weebly.com . Accessed 27th February 2018.</a:t>
+              <a:t>Müller, A.C. and Guido, S. (2017) </a:t>
+            </a:r>
+            <a:r>
+              <a:rPr lang="en-IE" sz="900" i="1" dirty="0">
+                <a:latin typeface="Times New Roman" panose="02020603050405020304" pitchFamily="18" charset="0"/>
+                <a:cs typeface="Times New Roman" panose="02020603050405020304" pitchFamily="18" charset="0"/>
+              </a:rPr>
+              <a:t>Introduction to Machine Learning with Python: A Guide for Data Scientists</a:t>
+            </a:r>
+            <a:r>
+              <a:rPr lang="en-IE" sz="900" dirty="0">
+                <a:latin typeface="Times New Roman" panose="02020603050405020304" pitchFamily="18" charset="0"/>
+                <a:cs typeface="Times New Roman" panose="02020603050405020304" pitchFamily="18" charset="0"/>
+              </a:rPr>
+              <a:t>. 1st end. Sebastopol, CA: O’Reilly Media.</a:t>
+            </a:r>
+          </a:p>
+          <a:p>
+            <a:pPr marL="0" indent="0" algn="just" defTabSz="895350">
+              <a:buNone/>
+            </a:pPr>
+            <a:r>
+              <a:rPr lang="en-IE" sz="900" dirty="0">
+                <a:latin typeface="Times New Roman" panose="02020603050405020304" pitchFamily="18" charset="0"/>
+                <a:cs typeface="Times New Roman" panose="02020603050405020304" pitchFamily="18" charset="0"/>
+              </a:rPr>
+              <a:t>Nugroho, W.H., Handovo, S. and Akri, Y.J. (2018) </a:t>
+            </a:r>
+            <a:r>
+              <a:rPr lang="en-IE" sz="900" i="1" dirty="0">
+                <a:latin typeface="Times New Roman" panose="02020603050405020304" pitchFamily="18" charset="0"/>
+                <a:cs typeface="Times New Roman" panose="02020603050405020304" pitchFamily="18" charset="0"/>
+              </a:rPr>
+              <a:t>An Influence of Measurement Scale of Predictor Variable on Logistic Regression Modeling and Learning Vector Quantization Modeling for Object Classification</a:t>
+            </a:r>
+            <a:r>
+              <a:rPr lang="en-IE" sz="900" dirty="0">
+                <a:latin typeface="Times New Roman" panose="02020603050405020304" pitchFamily="18" charset="0"/>
+                <a:cs typeface="Times New Roman" panose="02020603050405020304" pitchFamily="18" charset="0"/>
+              </a:rPr>
+              <a:t>. Available at: ResearchGate (Accessed: 11 May 2026). </a:t>
+            </a:r>
+          </a:p>
+          <a:p>
+            <a:pPr marL="0" indent="0" algn="just" defTabSz="895350">
+              <a:buNone/>
+            </a:pPr>
+            <a:r>
+              <a:rPr lang="en-IE" sz="900" dirty="0">
+                <a:latin typeface="Times New Roman" panose="02020603050405020304" pitchFamily="18" charset="0"/>
+                <a:cs typeface="Times New Roman" panose="02020603050405020304" pitchFamily="18" charset="0"/>
+              </a:rPr>
+              <a:t>O'Donovan, B. (2025) </a:t>
+            </a:r>
+            <a:r>
+              <a:rPr lang="en-IE" sz="900" i="1" dirty="0">
+                <a:latin typeface="Times New Roman" panose="02020603050405020304" pitchFamily="18" charset="0"/>
+                <a:cs typeface="Times New Roman" panose="02020603050405020304" pitchFamily="18" charset="0"/>
+              </a:rPr>
+              <a:t>Ireland at increased risk of cyber attacks - report</a:t>
+            </a:r>
+            <a:r>
+              <a:rPr lang="en-IE" sz="900" dirty="0">
+                <a:latin typeface="Times New Roman" panose="02020603050405020304" pitchFamily="18" charset="0"/>
+                <a:cs typeface="Times New Roman" panose="02020603050405020304" pitchFamily="18" charset="0"/>
+              </a:rPr>
+              <a:t>. Available at: RTÉ News (Accessed: 7 March 2026).</a:t>
+            </a:r>
+          </a:p>
+          <a:p>
+            <a:pPr marL="0" indent="0" algn="just" defTabSz="895350">
+              <a:buNone/>
+            </a:pPr>
+            <a:r>
+              <a:rPr lang="en-IE" sz="900" dirty="0">
+                <a:latin typeface="Times New Roman" panose="02020603050405020304" pitchFamily="18" charset="0"/>
+                <a:cs typeface="Times New Roman" panose="02020603050405020304" pitchFamily="18" charset="0"/>
+              </a:rPr>
+              <a:t>Schröer, C., Kruse, F. and Gómez, J.M. (2020) </a:t>
+            </a:r>
+            <a:r>
+              <a:rPr lang="en-IE" sz="900" i="1" dirty="0">
+                <a:latin typeface="Times New Roman" panose="02020603050405020304" pitchFamily="18" charset="0"/>
+                <a:cs typeface="Times New Roman" panose="02020603050405020304" pitchFamily="18" charset="0"/>
+              </a:rPr>
+              <a:t>A Systematic Literature Review on Applying CRISP-DM Process Model</a:t>
+            </a:r>
+            <a:r>
+              <a:rPr lang="en-IE" sz="900" dirty="0">
+                <a:latin typeface="Times New Roman" panose="02020603050405020304" pitchFamily="18" charset="0"/>
+                <a:cs typeface="Times New Roman" panose="02020603050405020304" pitchFamily="18" charset="0"/>
+              </a:rPr>
+              <a:t>. Available at: ScienceDirect (Accessed: 9 May 2026). Sharafaldin, I., Lashkari, A.H. and Ghorbani, A.A. (2018) </a:t>
+            </a:r>
+            <a:r>
+              <a:rPr lang="en-IE" sz="900" i="1" dirty="0">
+                <a:latin typeface="Times New Roman" panose="02020603050405020304" pitchFamily="18" charset="0"/>
+                <a:cs typeface="Times New Roman" panose="02020603050405020304" pitchFamily="18" charset="0"/>
+              </a:rPr>
+              <a:t>Intrusion detection evaluation dataset (CIC-IDS2017)</a:t>
+            </a:r>
+            <a:r>
+              <a:rPr lang="en-IE" sz="900" dirty="0">
+                <a:latin typeface="Times New Roman" panose="02020603050405020304" pitchFamily="18" charset="0"/>
+                <a:cs typeface="Times New Roman" panose="02020603050405020304" pitchFamily="18" charset="0"/>
+              </a:rPr>
+              <a:t>. Available at: UNB CIC Dataset.</a:t>
+            </a:r>
+          </a:p>
+          <a:p>
+            <a:pPr marL="0" indent="0" algn="just" defTabSz="895350">
+              <a:buNone/>
+            </a:pPr>
+            <a:r>
+              <a:rPr lang="en-IE" sz="900" dirty="0">
+                <a:latin typeface="Times New Roman" panose="02020603050405020304" pitchFamily="18" charset="0"/>
+                <a:cs typeface="Times New Roman" panose="02020603050405020304" pitchFamily="18" charset="0"/>
+              </a:rPr>
+              <a:t>Streamlit (2024) </a:t>
+            </a:r>
+            <a:r>
+              <a:rPr lang="en-IE" sz="900" i="1" dirty="0">
+                <a:latin typeface="Times New Roman" panose="02020603050405020304" pitchFamily="18" charset="0"/>
+                <a:cs typeface="Times New Roman" panose="02020603050405020304" pitchFamily="18" charset="0"/>
+              </a:rPr>
+              <a:t>Streamlit Docs</a:t>
+            </a:r>
+            <a:r>
+              <a:rPr lang="en-IE" sz="900" dirty="0">
+                <a:latin typeface="Times New Roman" panose="02020603050405020304" pitchFamily="18" charset="0"/>
+                <a:cs typeface="Times New Roman" panose="02020603050405020304" pitchFamily="18" charset="0"/>
+              </a:rPr>
+              <a:t>. Available at: Streamlit Documentation. </a:t>
+            </a:r>
+          </a:p>
+          <a:p>
+            <a:pPr marL="0" indent="0" algn="just" defTabSz="895350">
+              <a:buNone/>
+            </a:pPr>
+            <a:r>
+              <a:rPr lang="en-IE" sz="900" dirty="0">
+                <a:latin typeface="Times New Roman" panose="02020603050405020304" pitchFamily="18" charset="0"/>
+                <a:cs typeface="Times New Roman" panose="02020603050405020304" pitchFamily="18" charset="0"/>
+              </a:rPr>
+              <a:t>Zamani, S.Z. (2022) ‘Small and Medium Enterprises (SMEs) facing an evolving technological era: a systematic literature review on the adoption of technologies in SMEs’, </a:t>
+            </a:r>
+            <a:r>
+              <a:rPr lang="en-IE" sz="900" i="1" dirty="0">
+                <a:latin typeface="Times New Roman" panose="02020603050405020304" pitchFamily="18" charset="0"/>
+                <a:cs typeface="Times New Roman" panose="02020603050405020304" pitchFamily="18" charset="0"/>
+              </a:rPr>
+              <a:t>European Journal of Innovation Management</a:t>
+            </a:r>
+            <a:r>
+              <a:rPr lang="en-IE" sz="900" dirty="0">
+                <a:latin typeface="Times New Roman" panose="02020603050405020304" pitchFamily="18" charset="0"/>
+                <a:cs typeface="Times New Roman" panose="02020603050405020304" pitchFamily="18" charset="0"/>
+              </a:rPr>
+              <a:t>, 25(6). doi: DOI.</a:t>
             </a:r>
           </a:p>
           <a:p>
@@ -15512,21 +15455,63 @@
               <a:buNone/>
             </a:pPr>
             <a:endParaRPr lang="en-IE" sz="900" dirty="0">
-              <a:latin typeface="Arial" panose="020B0604020202020204" pitchFamily="34" charset="0"/>
-              <a:cs typeface="Arial" panose="020B0604020202020204" pitchFamily="34" charset="0"/>
+              <a:latin typeface="Times New Roman" panose="02020603050405020304" pitchFamily="18" charset="0"/>
+              <a:cs typeface="Times New Roman" panose="02020603050405020304" pitchFamily="18" charset="0"/>
             </a:endParaRPr>
           </a:p>
           <a:p>
             <a:pPr marL="0" indent="0" algn="just" defTabSz="895350">
               <a:buNone/>
             </a:pPr>
-            <a:r>
-              <a:rPr lang="en-IE" sz="900" dirty="0">
-                <a:latin typeface="Arial" panose="020B0604020202020204" pitchFamily="34" charset="0"/>
-                <a:cs typeface="Arial" panose="020B0604020202020204" pitchFamily="34" charset="0"/>
-              </a:rPr>
-              <a:t>Miles, M.B., &amp; Huberman, A.M. (1994). Qualitative data analysis: A sourcebook of new methods.  Thousand Oaks, CA: Sage.</a:t>
-            </a:r>
+            <a:endParaRPr lang="en-IE" sz="900" dirty="0">
+              <a:latin typeface="Times New Roman" panose="02020603050405020304" pitchFamily="18" charset="0"/>
+              <a:cs typeface="Times New Roman" panose="02020603050405020304" pitchFamily="18" charset="0"/>
+            </a:endParaRPr>
+          </a:p>
+          <a:p>
+            <a:pPr marL="0" indent="0" algn="just" defTabSz="895350">
+              <a:buNone/>
+            </a:pPr>
+            <a:endParaRPr lang="en-IE" sz="900" dirty="0">
+              <a:latin typeface="Times New Roman" panose="02020603050405020304" pitchFamily="18" charset="0"/>
+              <a:cs typeface="Times New Roman" panose="02020603050405020304" pitchFamily="18" charset="0"/>
+            </a:endParaRPr>
+          </a:p>
+          <a:p>
+            <a:pPr marL="0" indent="0" algn="just" defTabSz="895350">
+              <a:buNone/>
+            </a:pPr>
+            <a:endParaRPr lang="en-IE" sz="900" dirty="0">
+              <a:latin typeface="Times New Roman" panose="02020603050405020304" pitchFamily="18" charset="0"/>
+              <a:cs typeface="Times New Roman" panose="02020603050405020304" pitchFamily="18" charset="0"/>
+            </a:endParaRPr>
+          </a:p>
+          <a:p>
+            <a:pPr marL="0" indent="0" algn="just" defTabSz="895350">
+              <a:buNone/>
+            </a:pPr>
+            <a:endParaRPr lang="en-IE" sz="900" dirty="0">
+              <a:latin typeface="Times New Roman" panose="02020603050405020304" pitchFamily="18" charset="0"/>
+              <a:cs typeface="Times New Roman" panose="02020603050405020304" pitchFamily="18" charset="0"/>
+            </a:endParaRPr>
+          </a:p>
+          <a:p>
+            <a:pPr marL="0" indent="0" algn="just" defTabSz="895350">
+              <a:buNone/>
+            </a:pPr>
+            <a:endParaRPr lang="en-IE" sz="900" dirty="0">
+              <a:latin typeface="Times New Roman" panose="02020603050405020304" pitchFamily="18" charset="0"/>
+              <a:cs typeface="Times New Roman" panose="02020603050405020304" pitchFamily="18" charset="0"/>
+            </a:endParaRPr>
+          </a:p>
+          <a:p>
+            <a:pPr marL="0" indent="0" algn="just" defTabSz="895350">
+              <a:buNone/>
+            </a:pPr>
+            <a:endParaRPr lang="en-IE" sz="900" dirty="0">
+              <a:latin typeface="Times New Roman" panose="02020603050405020304" pitchFamily="18" charset="0"/>
+              <a:cs typeface="Times New Roman" panose="02020603050405020304" pitchFamily="18" charset="0"/>
+            </a:endParaRPr>
           </a:p>
         </p:txBody>
       </p:sp>
@@ -15558,7 +15543,7 @@
         </p:blipFill>
         <p:spPr>
           <a:xfrm>
-            <a:off x="2233763" y="20921667"/>
+            <a:off x="2128989" y="21120313"/>
             <a:ext cx="6339073" cy="6339073"/>
           </a:xfrm>
           <a:prstGeom prst="rect">
@@ -15921,23 +15906,7 @@
                   <a:schemeClr val="tx1"/>
                 </a:solidFill>
               </a:rPr>
-              <a:t>The Data Understanding phase focused on analyzing the CICIDS2017 dataset before preprocessing and modelling. The dataset was developed and publicly released by the Canadian Institute for Cybersecurity (CIC) at the University of New Brunswick, Canada, and contains benign and the most up-to-date common attacks, which resembles the true real-world data (PCAPs). It also includes the results of network traffics using </a:t>
-            </a:r>
-            <a:r>
-              <a:rPr lang="en-US" dirty="0" err="1">
-                <a:solidFill>
-                  <a:schemeClr val="tx1"/>
-                </a:solidFill>
-              </a:rPr>
-              <a:t>CICFlowMeter</a:t>
-            </a:r>
-            <a:r>
-              <a:rPr lang="en-US" dirty="0">
-                <a:solidFill>
-                  <a:schemeClr val="tx1"/>
-                </a:solidFill>
-              </a:rPr>
-              <a:t> with labeled flows based on the time stamp, source, and destination IPs, source and destination ports, protocols and attack </a:t>
+              <a:t>The Data Understanding phase focused on analyzing the CICIDS2017 dataset before preprocessing and modelling. The dataset was developed and publicly released by the Canadian Institute for Cybersecurity (CIC) at the University of New Brunswick, Canada, and contains benign and the most up-to-date common attacks, which resembles the true real-world data (PCAPs). It also includes the results of network traffics using CICFlowMeter with labeled flows based on the time stamp, source, and destination IPs, source and destination ports, protocols and attack </a:t>
             </a:r>
             <a:r>
               <a:rPr lang="en-IE" dirty="0">
@@ -15945,23 +15914,7 @@
                   <a:schemeClr val="tx1"/>
                 </a:solidFill>
               </a:rPr>
-              <a:t>(</a:t>
-            </a:r>
-            <a:r>
-              <a:rPr lang="en-IE" dirty="0" err="1">
-                <a:solidFill>
-                  <a:schemeClr val="tx1"/>
-                </a:solidFill>
-              </a:rPr>
-              <a:t>Sharafaldin</a:t>
-            </a:r>
-            <a:r>
-              <a:rPr lang="en-IE" dirty="0">
-                <a:solidFill>
-                  <a:schemeClr val="tx1"/>
-                </a:solidFill>
-              </a:rPr>
-              <a:t> et al., 2018).</a:t>
+              <a:t>(Sharafaldin et al., 2018).</a:t>
             </a:r>
             <a:endParaRPr lang="en-US" dirty="0">
               <a:solidFill>
@@ -15997,7 +15950,7 @@
           <p:nvPr/>
         </p:nvPicPr>
         <p:blipFill>
-          <a:blip r:embed="rId4">
+          <a:blip r:embed="rId4" cstate="print">
             <a:extLst>
               <a:ext uri="{28A0092B-C50C-407E-A947-70E740481C1C}">
                 <a14:useLocalDpi xmlns:a14="http://schemas.microsoft.com/office/drawing/2010/main" val="0"/>
@@ -16767,7 +16720,7 @@
         <p:spPr>
           <a:xfrm>
             <a:off x="11491690" y="23322901"/>
-            <a:ext cx="9680489" cy="6710281"/>
+            <a:ext cx="9897972" cy="7385699"/>
           </a:xfrm>
           <a:prstGeom prst="rect">
             <a:avLst/>
@@ -17476,20 +17429,12 @@
               <a:t>Baseline and balanced versions were tested using </a:t>
             </a:r>
             <a:r>
-              <a:rPr lang="en-US" sz="2400" i="1" dirty="0" err="1">
+              <a:rPr lang="en-US" sz="2400" i="1" dirty="0">
                 <a:solidFill>
                   <a:schemeClr val="tx1"/>
                 </a:solidFill>
               </a:rPr>
-              <a:t>class_weight</a:t>
-            </a:r>
-            <a:r>
-              <a:rPr lang="en-US" sz="2400" i="1" dirty="0">
-                <a:solidFill>
-                  <a:schemeClr val="tx1"/>
-                </a:solidFill>
-              </a:rPr>
-              <a:t>=“balanced”</a:t>
+              <a:t>class_weight=“balanced”</a:t>
             </a:r>
             <a:r>
               <a:rPr lang="en-US" sz="2400" dirty="0">
@@ -17538,80 +17483,40 @@
                   <a:schemeClr val="tx1"/>
                 </a:solidFill>
               </a:rPr>
-              <a:t>criterion = “</a:t>
-            </a:r>
-            <a:r>
-              <a:rPr lang="en-US" sz="2000" i="1" dirty="0" err="1">
-                <a:solidFill>
-                  <a:schemeClr val="tx1"/>
-                </a:solidFill>
-              </a:rPr>
-              <a:t>log_loss</a:t>
-            </a:r>
-            <a:r>
-              <a:rPr lang="en-US" sz="2000" i="1" dirty="0">
-                <a:solidFill>
-                  <a:schemeClr val="tx1"/>
-                </a:solidFill>
-              </a:rPr>
-              <a:t>”</a:t>
+              <a:t>criterion = “log_loss”</a:t>
             </a:r>
           </a:p>
           <a:p>
             <a:pPr algn="ctr"/>
             <a:r>
-              <a:rPr lang="en-US" sz="2000" i="1" dirty="0" err="1">
+              <a:rPr lang="en-US" sz="2000" i="1" dirty="0">
                 <a:solidFill>
                   <a:schemeClr val="tx1"/>
                 </a:solidFill>
               </a:rPr>
-              <a:t>class_weight</a:t>
-            </a:r>
-            <a:r>
-              <a:rPr lang="en-US" sz="2000" i="1" dirty="0">
-                <a:solidFill>
-                  <a:schemeClr val="tx1"/>
-                </a:solidFill>
-              </a:rPr>
-              <a:t> = “balanced”</a:t>
+              <a:t>class_weight = “balanced”</a:t>
             </a:r>
           </a:p>
           <a:p>
             <a:pPr algn="ctr"/>
             <a:r>
-              <a:rPr lang="en-US" sz="2000" i="1" dirty="0" err="1">
+              <a:rPr lang="en-US" sz="2000" i="1" dirty="0">
                 <a:solidFill>
                   <a:schemeClr val="tx1"/>
                 </a:solidFill>
               </a:rPr>
-              <a:t>min_samples_split</a:t>
-            </a:r>
-            <a:r>
-              <a:rPr lang="en-US" sz="2000" i="1" dirty="0">
-                <a:solidFill>
-                  <a:schemeClr val="tx1"/>
-                </a:solidFill>
-              </a:rPr>
-              <a:t> = 3</a:t>
+              <a:t>min_samples_split = 3</a:t>
             </a:r>
           </a:p>
           <a:p>
             <a:pPr algn="ctr"/>
             <a:r>
-              <a:rPr lang="en-US" sz="2000" i="1" dirty="0" err="1">
+              <a:rPr lang="en-US" sz="2000" i="1" dirty="0">
                 <a:solidFill>
                   <a:schemeClr val="tx1"/>
                 </a:solidFill>
               </a:rPr>
-              <a:t>random_state</a:t>
-            </a:r>
-            <a:r>
-              <a:rPr lang="en-US" sz="2000" i="1" dirty="0">
-                <a:solidFill>
-                  <a:schemeClr val="tx1"/>
-                </a:solidFill>
-              </a:rPr>
-              <a:t> = 42</a:t>
+              <a:t>random_state = 42</a:t>
             </a:r>
           </a:p>
         </p:txBody>
@@ -17864,15 +17769,7 @@
                   <a:schemeClr val="tx1"/>
                 </a:solidFill>
               </a:rPr>
-              <a:t>This model kept all traffic classes and performed strongly on the main classes, while still detecting some rare attacks such as Heartbleed, Infiltration and SQL Injection</a:t>
-            </a:r>
-            <a:r>
-              <a:rPr lang="en-US" sz="2000" dirty="0">
-                <a:solidFill>
-                  <a:schemeClr val="tx1"/>
-                </a:solidFill>
-              </a:rPr>
-              <a:t>.</a:t>
+              <a:t>This model kept all traffic classes and performed strongly on the main classes, while still detecting some rare attacks such as Heartbleed, Infiltration and SQL Injection.</a:t>
             </a:r>
           </a:p>
         </p:txBody>
@@ -17905,8 +17802,8 @@
         </p:blipFill>
         <p:spPr>
           <a:xfrm>
-            <a:off x="22971033" y="21908743"/>
-            <a:ext cx="8891903" cy="7117465"/>
+            <a:off x="22584329" y="22416988"/>
+            <a:ext cx="9600583" cy="7117465"/>
           </a:xfrm>
           <a:prstGeom prst="rect">
             <a:avLst/>
@@ -17930,7 +17827,7 @@
         <p:spPr>
           <a:xfrm>
             <a:off x="33382622" y="6439621"/>
-            <a:ext cx="10048874" cy="5309123"/>
+            <a:ext cx="10048874" cy="4924403"/>
           </a:xfrm>
           <a:prstGeom prst="rect">
             <a:avLst/>
@@ -18087,39 +17984,7 @@
                   <a:schemeClr val="tx1"/>
                 </a:solidFill>
               </a:rPr>
-              <a:t>A </a:t>
-            </a:r>
-            <a:r>
-              <a:rPr lang="en-US" dirty="0" err="1">
-                <a:solidFill>
-                  <a:schemeClr val="tx1"/>
-                </a:solidFill>
-              </a:rPr>
-              <a:t>Streamlit</a:t>
-            </a:r>
-            <a:r>
-              <a:rPr lang="en-US" dirty="0">
-                <a:solidFill>
-                  <a:schemeClr val="tx1"/>
-                </a:solidFill>
-              </a:rPr>
-              <a:t> dashboard prototype was created to demonstrate how the final model could be reused outside the notebook (</a:t>
-            </a:r>
-            <a:r>
-              <a:rPr lang="en-US" dirty="0" err="1">
-                <a:solidFill>
-                  <a:schemeClr val="tx1"/>
-                </a:solidFill>
-              </a:rPr>
-              <a:t>Streamlit</a:t>
-            </a:r>
-            <a:r>
-              <a:rPr lang="en-US" dirty="0">
-                <a:solidFill>
-                  <a:schemeClr val="tx1"/>
-                </a:solidFill>
-              </a:rPr>
-              <a:t>, 2024).</a:t>
+              <a:t>A Streamlit dashboard prototype was created to demonstrate how the final model could be reused outside the notebook (Streamlit, 2024).</a:t>
             </a:r>
           </a:p>
           <a:p>
@@ -18130,23 +17995,7 @@
                   <a:schemeClr val="tx1"/>
                 </a:solidFill>
               </a:rPr>
-              <a:t>The final Decision Tree model was saved using </a:t>
-            </a:r>
-            <a:r>
-              <a:rPr lang="en-US" dirty="0" err="1">
-                <a:solidFill>
-                  <a:schemeClr val="tx1"/>
-                </a:solidFill>
-              </a:rPr>
-              <a:t>Joblib</a:t>
-            </a:r>
-            <a:r>
-              <a:rPr lang="en-US" dirty="0">
-                <a:solidFill>
-                  <a:schemeClr val="tx1"/>
-                </a:solidFill>
-              </a:rPr>
-              <a:t> together with the selected 39 features, label encoder, and trained model file (McQuaid, 2026d).</a:t>
+              <a:t>The final Decision Tree model was saved using Joblib together with the selected 39 features, label encoder, and trained model file (McQuaid, 2026d).</a:t>
             </a:r>
           </a:p>
           <a:p>
@@ -18168,7 +18017,7 @@
                   <a:schemeClr val="tx1"/>
                 </a:solidFill>
               </a:rPr>
-              <a:t>This is still a prototype, not a full production IDS. It does not capture live network packets directly yet. Future work would require live traffic extraction, more testing, newer data and model retraining.</a:t>
+              <a:t>This is still a prototype, not a full production IDS. It does not capture live network packets directly yet.</a:t>
             </a:r>
           </a:p>
         </p:txBody>
@@ -18201,7 +18050,7 @@
         </p:blipFill>
         <p:spPr>
           <a:xfrm>
-            <a:off x="33755535" y="11594463"/>
+            <a:off x="33723344" y="11344774"/>
             <a:ext cx="9293216" cy="3713043"/>
           </a:xfrm>
           <a:prstGeom prst="rect">
@@ -18237,7 +18086,7 @@
         </p:blipFill>
         <p:spPr>
           <a:xfrm>
-            <a:off x="33754050" y="15636954"/>
+            <a:off x="33723344" y="15506196"/>
             <a:ext cx="9293216" cy="3914331"/>
           </a:xfrm>
           <a:prstGeom prst="rect">
@@ -18259,7 +18108,7 @@
         </p:nvSpPr>
         <p:spPr>
           <a:xfrm>
-            <a:off x="36629750" y="15318342"/>
+            <a:off x="36629750" y="15135116"/>
             <a:ext cx="3503716" cy="307777"/>
           </a:xfrm>
           <a:prstGeom prst="rect">
@@ -18278,21 +18127,7 @@
                 <a:latin typeface="Times New Roman" panose="02020603050405020304" pitchFamily="18" charset="0"/>
                 <a:cs typeface="Times New Roman" panose="02020603050405020304" pitchFamily="18" charset="0"/>
               </a:rPr>
-              <a:t>Initial </a:t>
-            </a:r>
-            <a:r>
-              <a:rPr lang="en-IE" sz="1400" i="1" dirty="0" err="1">
-                <a:latin typeface="Times New Roman" panose="02020603050405020304" pitchFamily="18" charset="0"/>
-                <a:cs typeface="Times New Roman" panose="02020603050405020304" pitchFamily="18" charset="0"/>
-              </a:rPr>
-              <a:t>Streamlit</a:t>
-            </a:r>
-            <a:r>
-              <a:rPr lang="en-IE" sz="1400" i="1" dirty="0">
-                <a:latin typeface="Times New Roman" panose="02020603050405020304" pitchFamily="18" charset="0"/>
-                <a:cs typeface="Times New Roman" panose="02020603050405020304" pitchFamily="18" charset="0"/>
-              </a:rPr>
-              <a:t> IDS dashboard upload screen</a:t>
+              <a:t>Initial Streamlit IDS dashboard upload screen</a:t>
             </a:r>
           </a:p>
         </p:txBody>
@@ -18311,7 +18146,7 @@
         </p:nvSpPr>
         <p:spPr>
           <a:xfrm>
-            <a:off x="35515919" y="19533620"/>
+            <a:off x="35515919" y="19486494"/>
             <a:ext cx="5731377" cy="307777"/>
           </a:xfrm>
           <a:prstGeom prst="rect">
@@ -18363,7 +18198,7 @@
         </p:blipFill>
         <p:spPr>
           <a:xfrm>
-            <a:off x="33754050" y="19853256"/>
+            <a:off x="33754050" y="19801653"/>
             <a:ext cx="9355112" cy="4234537"/>
           </a:xfrm>
           <a:prstGeom prst="rect">
@@ -18423,8 +18258,8 @@
         </p:nvSpPr>
         <p:spPr>
           <a:xfrm>
-            <a:off x="33566814" y="25108679"/>
-            <a:ext cx="9680489" cy="3554819"/>
+            <a:off x="33560413" y="24894509"/>
+            <a:ext cx="9680489" cy="5262979"/>
           </a:xfrm>
           <a:prstGeom prst="rect">
             <a:avLst/>
@@ -18439,26 +18274,26 @@
           <a:p>
             <a:pPr algn="just"/>
             <a:r>
-              <a:rPr lang="en-IE" sz="2500" dirty="0">
+              <a:rPr lang="en-IE" sz="2400" dirty="0">
                 <a:latin typeface="Times New Roman" panose="02020603050405020304" pitchFamily="18" charset="0"/>
                 <a:cs typeface="Times New Roman" panose="02020603050405020304" pitchFamily="18" charset="0"/>
               </a:rPr>
-              <a:t>The project shows that a lightweight machine learning IDS can support the detection of benign and malicious network traffic using CICIDS2017. Decision Tree – Full Dataset Balanced Tuned 2 was selected as the final model because it offered the best balance between performance, runtime, interpretability and attack coverage. The </a:t>
+              <a:t>The project shows that a lightweight machine learning IDS can support the detection of benign and malicious network traffic using CICIDS2017. Decision Tree – Full Dataset Balanced Tuned 2 was selected as the final model because it offered the best balance between performance, runtime, interpretability and attack coverage. The Streamlit prototype showed how the saved model could be reused for traffic prediction and suspicious traffic summaries. </a:t>
             </a:r>
+          </a:p>
+          <a:p>
+            <a:pPr algn="just"/>
             <a:r>
-              <a:rPr lang="en-IE" sz="2500" dirty="0" err="1">
+              <a:rPr lang="en-US" sz="2400" dirty="0">
                 <a:latin typeface="Times New Roman" panose="02020603050405020304" pitchFamily="18" charset="0"/>
                 <a:cs typeface="Times New Roman" panose="02020603050405020304" pitchFamily="18" charset="0"/>
               </a:rPr>
-              <a:t>Streamlit</a:t>
+              <a:t>Future improvements for this project could include integrating live network traffic capture for real-time IDS monitoring, retraining the models using newer cybersecurity datasets to improve attack detection, and expanding the Streamlit dashboard with automated alerts and advanced monitoring features. Future research could also compare lightweight machine learning models with deep learning approaches to analyze performance and computational trade-offs.</a:t>
             </a:r>
-            <a:r>
-              <a:rPr lang="en-IE" sz="2500" dirty="0">
-                <a:latin typeface="Times New Roman" panose="02020603050405020304" pitchFamily="18" charset="0"/>
-                <a:cs typeface="Times New Roman" panose="02020603050405020304" pitchFamily="18" charset="0"/>
-              </a:rPr>
-              <a:t> prototype showed how the saved model could be reused for traffic prediction and suspicious traffic summaries. However, the system is still a prototype and would need newer data, live traffic extraction, further testing and retraining before real-world use.</a:t>
-            </a:r>
+            <a:endParaRPr lang="en-IE" sz="2400" dirty="0">
+              <a:latin typeface="Times New Roman" panose="02020603050405020304" pitchFamily="18" charset="0"/>
+              <a:cs typeface="Times New Roman" panose="02020603050405020304" pitchFamily="18" charset="0"/>
+            </a:endParaRPr>
           </a:p>
         </p:txBody>
       </p:sp>

</xml_diff>

<commit_message>
chore: finalised complete CA2 IDS project submission
Finalised the complete CA2 IDS project submission package.

Updated and organised all final project artefacts, including the final report, Jupyter notebook, Streamlit dashboard app, saved model files, poster, presentation slides, dashboard user guide, dataset link file, cover sheet, README, dashboard test sample, CICIDS2017 datasets and previous supporting materials.

Included the final Decision Tree Full Dataset Balanced Tuned 2 model, label encoder and selected feature list required for the Streamlit dashboard prototype.

Confirmed the final documentation, notebook outputs, dashboard workflow, model files and supporting materials are aligned with the final project results and ready for Moodle submission and GitHub evidence.
</commit_message>
<xml_diff>
--- a/Poster Presentation.pptx
+++ b/Poster Presentation.pptx
@@ -286,7 +286,7 @@
             <a:fld id="{0158C5BC-9A70-462C-B28D-9600239EAC64}" type="datetimeFigureOut">
               <a:rPr lang="en-US" smtClean="0"/>
               <a:pPr/>
-              <a:t>5/28/2026</a:t>
+              <a:t>5/30/26</a:t>
             </a:fld>
             <a:endParaRPr lang="en-US" dirty="0"/>
           </a:p>
@@ -453,7 +453,7 @@
             <a:fld id="{E6CC2317-6751-4CD4-9995-8782DD78E936}" type="datetimeFigureOut">
               <a:rPr lang="en-US" smtClean="0"/>
               <a:pPr/>
-              <a:t>5/28/2026</a:t>
+              <a:t>5/30/26</a:t>
             </a:fld>
             <a:endParaRPr lang="en-US" dirty="0"/>
           </a:p>
@@ -15906,7 +15906,7 @@
                   <a:schemeClr val="tx1"/>
                 </a:solidFill>
               </a:rPr>
-              <a:t>The Data Understanding phase focused on analyzing the CICIDS2017 dataset before preprocessing and modelling. The dataset was developed and publicly released by the Canadian Institute for Cybersecurity (CIC) at the University of New Brunswick, Canada, and contains benign and the most up-to-date common attacks, which resembles the true real-world data (PCAPs). It also includes the results of network traffics using CICFlowMeter with labeled flows based on the time stamp, source, and destination IPs, source and destination ports, protocols and attack </a:t>
+              <a:t>The Data Understanding phase focused on analyzing the CICIDS2017 dataset before preprocessing and modelling. The dataset was developed and publicly released by the Canadian Institute for Cybersecurity (CIC) at the University of New Brunswick, Canada, and contains benign and the most up-to-date common attacks, which resembles the true real-world data (PCAPs). It also includes the results of network traffic using CICFlowMeter with labeled flows based on the time stamp, source, and destination IPs, source and destination ports, protocols and attack </a:t>
             </a:r>
             <a:r>
               <a:rPr lang="en-IE" dirty="0">
@@ -15930,7 +15930,7 @@
                   <a:schemeClr val="tx1"/>
                 </a:solidFill>
               </a:rPr>
-              <a:t>The dataset was presented in 8 different CSV files, with different traffic’s period and attacks scenario. The dataset after merging had 2,830,743 rows and 79 columns. A total of 1,358 missing values were removed, and we constate that the dataset was very unbalanced, having 80.3% of benign traffic.</a:t>
+              <a:t>The dataset was presented in 8 different CSV files, with different traffic’s period and attacks scenario. The dataset after merging had 2,830,743 rows and 79 columns. A total of 1,358 missing values were removed, and we observed that the dataset was very unbalanced, having 80.3% of benign traffic.</a:t>
             </a:r>
           </a:p>
         </p:txBody>

</xml_diff>